<commit_message>
Corrige une formulation sur la diapositive des choix de conception
</commit_message>
<xml_diff>
--- a/docs/NexaWorks-Soutenance.pptx
+++ b/docs/NexaWorks-Soutenance.pptx
@@ -4,6 +4,9 @@
   <p:sldMasterIdLst>
     <p:sldMasterId id="2147483648" r:id="rId1"/>
   </p:sldMasterIdLst>
+  <p:notesMasterIdLst>
+    <p:notesMasterId r:id="rId15"/>
+  </p:notesMasterIdLst>
   <p:sldIdLst>
     <p:sldId id="256" r:id="rId2"/>
     <p:sldId id="257" r:id="rId3"/>
@@ -19,9 +22,6 @@
     <p:sldId id="267" r:id="rId13"/>
     <p:sldId id="268" r:id="rId14"/>
   </p:sldIdLst>
-  <p:notesMasterIdLst>
-    <p:notesMasterId r:id="rId15"/>
-  </p:notesMasterIdLst>
   <p:sldSz cx="12192000" cy="6858000"/>
   <p:notesSz cx="6858000" cy="12192000"/>
   <p:defaultTextStyle>
@@ -116,6 +116,11 @@
       </a:defRPr>
     </a:lvl9pPr>
   </p:defaultTextStyle>
+  <p:extLst>
+    <p:ext uri="{EFAFB233-063F-42B5-8137-9DF3F51BA10A}">
+      <p15:sldGuideLst xmlns:p15="http://schemas.microsoft.com/office/powerpoint/2012/main"/>
+    </p:ext>
+  </p:extLst>
 </p:presentation>
 </file>
 
@@ -141,234 +146,10 @@
           <a:chExt cx="0" cy="0"/>
         </a:xfrm>
       </p:grpSpPr>
-      <p:sp>
-        <p:nvSpPr>
-          <p:cNvPr id="2" name="Header Placeholder 1"/>
-          <p:cNvSpPr>
-            <a:spLocks noGrp="1"/>
-          </p:cNvSpPr>
-          <p:nvPr>
-            <p:ph type="hdr" sz="quarter"/>
-          </p:nvPr>
-        </p:nvSpPr>
-        <p:spPr>
-          <a:xfrm>
-            <a:off x="0" y="0"/>
-            <a:ext cx="2971800" cy="458788"/>
-          </a:xfrm>
-          <a:prstGeom prst="rect">
-            <a:avLst/>
-          </a:prstGeom>
-        </p:spPr>
-        <p:txBody>
-          <a:bodyPr vert="horz" lIns="91440" tIns="45720" rIns="91440" bIns="45720" rtlCol="0"/>
-          <a:lstStyle>
-            <a:lvl1pPr algn="l">
-              <a:defRPr sz="1200"/>
-            </a:lvl1pPr>
-          </a:lstStyle>
-          <a:p>
-            <a:endParaRPr lang="en-US"/>
-          </a:p>
-        </p:txBody>
-      </p:sp>
-      <p:sp>
-        <p:nvSpPr>
-          <p:cNvPr id="3" name="Date Placeholder 2"/>
-          <p:cNvSpPr>
-            <a:spLocks noGrp="1"/>
-          </p:cNvSpPr>
-          <p:nvPr>
-            <p:ph type="dt" idx="1"/>
-          </p:nvPr>
-        </p:nvSpPr>
-        <p:spPr>
-          <a:xfrm>
-            <a:off x="3884613" y="0"/>
-            <a:ext cx="2971800" cy="458788"/>
-          </a:xfrm>
-          <a:prstGeom prst="rect">
-            <a:avLst/>
-          </a:prstGeom>
-        </p:spPr>
-        <p:txBody>
-          <a:bodyPr vert="horz" lIns="91440" tIns="45720" rIns="91440" bIns="45720" rtlCol="0"/>
-          <a:lstStyle>
-            <a:lvl1pPr algn="r">
-              <a:defRPr sz="1200"/>
-            </a:lvl1pPr>
-          </a:lstStyle>
-          <a:p>
-            <a:fld id="{5282F153-3F37-0F45-9E97-73ACFA13230C}" type="datetimeFigureOut">
-              <a:rPr lang="en-US"/>
-              <a:t>7/23/19</a:t>
-            </a:fld>
-            <a:endParaRPr lang="en-US"/>
-          </a:p>
-        </p:txBody>
-      </p:sp>
-      <p:sp>
-        <p:nvSpPr>
-          <p:cNvPr id="4" name="Slide Image Placeholder 3"/>
-          <p:cNvSpPr>
-            <a:spLocks noGrp="1" noRot="1" noChangeAspect="1"/>
-          </p:cNvSpPr>
-          <p:nvPr>
-            <p:ph type="sldImg" idx="2"/>
-          </p:nvPr>
-        </p:nvSpPr>
-        <p:spPr>
-          <a:xfrm>
-            <a:off x="685800" y="1143000"/>
-            <a:ext cx="5486400" cy="3086100"/>
-          </a:xfrm>
-          <a:prstGeom prst="rect">
-            <a:avLst/>
-          </a:prstGeom>
-          <a:noFill/>
-          <a:ln w="12700">
-            <a:solidFill>
-              <a:prstClr val="black"/>
-            </a:solidFill>
-          </a:ln>
-        </p:spPr>
-        <p:txBody>
-          <a:bodyPr vert="horz" lIns="91440" tIns="45720" rIns="91440" bIns="45720" rtlCol="0" anchor="ctr"/>
-          <a:lstStyle/>
-          <a:p>
-            <a:endParaRPr lang="en-US"/>
-          </a:p>
-        </p:txBody>
-      </p:sp>
-      <p:sp>
-        <p:nvSpPr>
-          <p:cNvPr id="5" name="Notes Placeholder 4"/>
-          <p:cNvSpPr>
-            <a:spLocks noGrp="1"/>
-          </p:cNvSpPr>
-          <p:nvPr>
-            <p:ph type="body" sz="quarter" idx="3"/>
-          </p:nvPr>
-        </p:nvSpPr>
-        <p:spPr>
-          <a:xfrm>
-            <a:off x="685800" y="4400550"/>
-            <a:ext cx="5486400" cy="3600450"/>
-          </a:xfrm>
-          <a:prstGeom prst="rect">
-            <a:avLst/>
-          </a:prstGeom>
-        </p:spPr>
-        <p:txBody>
-          <a:bodyPr vert="horz" lIns="91440" tIns="45720" rIns="91440" bIns="45720" rtlCol="0"/>
-          <a:lstStyle/>
-          <a:p>
-            <a:pPr lvl="0"/>
-            <a:r>
-              <a:rPr lang="en-US"/>
-              <a:t>Click to edit Master text styles</a:t>
-            </a:r>
-          </a:p>
-          <a:p>
-            <a:pPr lvl="1"/>
-            <a:r>
-              <a:rPr lang="en-US"/>
-              <a:t>Second level</a:t>
-            </a:r>
-          </a:p>
-          <a:p>
-            <a:pPr lvl="2"/>
-            <a:r>
-              <a:rPr lang="en-US"/>
-              <a:t>Third level</a:t>
-            </a:r>
-          </a:p>
-          <a:p>
-            <a:pPr lvl="3"/>
-            <a:r>
-              <a:rPr lang="en-US"/>
-              <a:t>Fourth level</a:t>
-            </a:r>
-          </a:p>
-          <a:p>
-            <a:pPr lvl="4"/>
-            <a:r>
-              <a:rPr lang="en-US"/>
-              <a:t>Fifth level</a:t>
-            </a:r>
-          </a:p>
-        </p:txBody>
-      </p:sp>
-      <p:sp>
-        <p:nvSpPr>
-          <p:cNvPr id="6" name="Footer Placeholder 5"/>
-          <p:cNvSpPr>
-            <a:spLocks noGrp="1"/>
-          </p:cNvSpPr>
-          <p:nvPr>
-            <p:ph type="ftr" sz="quarter" idx="4"/>
-          </p:nvPr>
-        </p:nvSpPr>
-        <p:spPr>
-          <a:xfrm>
-            <a:off x="0" y="8685213"/>
-            <a:ext cx="2971800" cy="458787"/>
-          </a:xfrm>
-          <a:prstGeom prst="rect">
-            <a:avLst/>
-          </a:prstGeom>
-        </p:spPr>
-        <p:txBody>
-          <a:bodyPr vert="horz" lIns="91440" tIns="45720" rIns="91440" bIns="45720" rtlCol="0" anchor="b"/>
-          <a:lstStyle>
-            <a:lvl1pPr algn="l">
-              <a:defRPr sz="1200"/>
-            </a:lvl1pPr>
-          </a:lstStyle>
-          <a:p>
-            <a:endParaRPr lang="en-US"/>
-          </a:p>
-        </p:txBody>
-      </p:sp>
-      <p:sp>
-        <p:nvSpPr>
-          <p:cNvPr id="7" name="Slide Number Placeholder 6"/>
-          <p:cNvSpPr>
-            <a:spLocks noGrp="1"/>
-          </p:cNvSpPr>
-          <p:nvPr>
-            <p:ph type="sldNum" sz="quarter" idx="5"/>
-          </p:nvPr>
-        </p:nvSpPr>
-        <p:spPr>
-          <a:xfrm>
-            <a:off x="3884613" y="8685213"/>
-            <a:ext cx="2971800" cy="458787"/>
-          </a:xfrm>
-          <a:prstGeom prst="rect">
-            <a:avLst/>
-          </a:prstGeom>
-        </p:spPr>
-        <p:txBody>
-          <a:bodyPr vert="horz" lIns="91440" tIns="45720" rIns="91440" bIns="45720" rtlCol="0" anchor="b"/>
-          <a:lstStyle>
-            <a:lvl1pPr algn="r">
-              <a:defRPr sz="1200"/>
-            </a:lvl1pPr>
-          </a:lstStyle>
-          <a:p>
-            <a:fld id="{CE5E9CC1-C706-0F49-92D6-E571CC5EEA8F}" type="slidenum">
-              <a:rPr lang="en-US"/>
-              <a:t>‹#›</a:t>
-            </a:fld>
-            <a:endParaRPr lang="en-US"/>
-          </a:p>
-        </p:txBody>
-      </p:sp>
     </p:spTree>
     <p:extLst>
       <p:ext uri="{BB962C8B-B14F-4D97-AF65-F5344CB8AC3E}">
-        <p14:creationId xmlns:p14="http://schemas.microsoft.com/office/powerpoint/2010/main" val="1024086991"/>
+        <p14:creationId xmlns:p14="http://schemas.microsoft.com/office/powerpoint/2010/main" val="3279842671"/>
       </p:ext>
     </p:extLst>
   </p:cSld>
@@ -514,9 +295,24 @@
           <a:p>
             <a:r>
               <a:rPr lang="en-US" dirty="0"/>
-              <a:t>Bonjour, je vais vous présenter le projet NexaWorks : la conception et la création d'une base de données pour suivre les problèmes des logiciels de l'entreprise. Je commencerai par vous montrer la solution qui fonctionne, puis je détaillerai comment je l'ai construite.</a:t>
-            </a:r>
-            <a:endParaRPr lang="en-US" dirty="0"/>
+              <a:t>Bonjour, je vais vous présenter le projet </a:t>
+            </a:r>
+            <a:r>
+              <a:rPr lang="en-US"/>
+              <a:t>NexaWorks qui consiste en </a:t>
+            </a:r>
+            <a:r>
+              <a:rPr lang="en-US" dirty="0"/>
+              <a:t>la conception et la création d'une base de données pour suivre les problèmes des logiciels de l'entreprise. </a:t>
+            </a:r>
+            <a:r>
+              <a:rPr lang="en-US"/>
+              <a:t>Je commence </a:t>
+            </a:r>
+            <a:r>
+              <a:rPr lang="en-US" dirty="0"/>
+              <a:t>par vous montrer la solution qui fonctionne, puis je détaillerai comment je l'ai construite.</a:t>
+            </a:r>
           </a:p>
         </p:txBody>
       </p:sp>
@@ -601,8 +397,32 @@
           <a:lstStyle/>
           <a:p>
             <a:r>
+              <a:rPr lang="en-US"/>
+              <a:t>L'optimisation des requêtes: </a:t>
+            </a:r>
+            <a:r>
               <a:rPr lang="en-US" dirty="0"/>
-              <a:t>Le cœur de l'optimisation : les 20 requêtes ne varient que par cinq critères : statut, produit, version, période, mots-clés. J'en ai fait une seule requête paramétrée, où chaque critère est optionnel. Un paramètre vide est ignoré. Cette unique requête répond aux 20 demandes, bien en dessous de la limite de 20.</a:t>
+              <a:t>les 20 requêtes ne varient que par cinq critères : statut, produit, version</a:t>
+            </a:r>
+            <a:r>
+              <a:rPr lang="en-US"/>
+              <a:t>, période et </a:t>
+            </a:r>
+            <a:r>
+              <a:rPr lang="en-US" dirty="0"/>
+              <a:t>mots-clés</a:t>
+            </a:r>
+            <a:r>
+              <a:rPr lang="en-US"/>
+              <a:t>. Une </a:t>
+            </a:r>
+            <a:r>
+              <a:rPr lang="en-US" dirty="0"/>
+              <a:t>seule requête paramétrée, où chaque critère est optionnel. Un paramètre vide est ignoré. Cette unique requête répond aux </a:t>
+            </a:r>
+            <a:r>
+              <a:rPr lang="en-US"/>
+              <a:t>20 demandes.</a:t>
             </a:r>
             <a:endParaRPr lang="en-US" dirty="0"/>
           </a:p>
@@ -690,9 +510,22 @@
           <a:p>
             <a:r>
               <a:rPr lang="en-US" dirty="0"/>
-              <a:t>J'ai fourni la requête de deux façons : en LINQ dans le projet .NET, et en procédure stockée T-SQL dans la base. La version LINQ construit les filtres à la volée et se traduit en une seule requête SQL ; la procédure utilise le motif paramètre-vide-ou-condition. Les deux donnent exactement les mêmes résultats.</a:t>
-            </a:r>
-            <a:endParaRPr lang="en-US" dirty="0"/>
+              <a:t>J'ai fourni la requête de deux façons : en LINQ dans le projet .NET, et en procédure stockée T-SQL dans la base. La version LINQ construit les filtres à la volée et se traduit en une seule </a:t>
+            </a:r>
+            <a:r>
+              <a:rPr lang="en-US"/>
+              <a:t>requête SQL.</a:t>
+            </a:r>
+          </a:p>
+          <a:p>
+            <a:r>
+              <a:rPr lang="en-US"/>
+              <a:t>La procedure stockée </a:t>
+            </a:r>
+            <a:r>
+              <a:rPr lang="en-US" dirty="0"/>
+              <a:t>utilise le motif paramètre-vide-ou-condition. Les deux donnent exactement les mêmes résultats.</a:t>
+            </a:r>
           </a:p>
         </p:txBody>
       </p:sp>
@@ -780,7 +613,6 @@
               <a:rPr lang="en-US" dirty="0"/>
               <a:t>Côté documentation, un fichier Excel reprend les 20 demandes avec pour chacune le but, les paramètres, le résultat attendu et le résultat obtenu. Enfin, une sauvegarde complète de la base au format .bak, restaurable ailleurs, est déposée sur GitHub avec l'ensemble du projet.</a:t>
             </a:r>
-            <a:endParaRPr lang="en-US" dirty="0"/>
           </a:p>
         </p:txBody>
       </p:sp>
@@ -865,10 +697,45 @@
           <a:lstStyle/>
           <a:p>
             <a:r>
+              <a:rPr lang="en-US"/>
+              <a:t>Ce </a:t>
+            </a:r>
+            <a:r>
               <a:rPr lang="en-US" dirty="0"/>
-              <a:t>En bilan, ce projet m'a fait progresser sur la modélisation et la normalisation, sur la création d'une base en Code-First avec EF Core, sur l'interrogation en LINQ et en SQL avec l'optimisation des requêtes, et sur la rigueur des livrables. Je vous remercie et je réponds à vos questions.</a:t>
-            </a:r>
-            <a:endParaRPr lang="en-US" dirty="0"/>
+              <a:t>projet m'a fait progresser sur </a:t>
+            </a:r>
+            <a:r>
+              <a:rPr lang="en-US"/>
+              <a:t>la conception </a:t>
+            </a:r>
+            <a:r>
+              <a:rPr lang="en-US" dirty="0"/>
+              <a:t>et </a:t>
+            </a:r>
+            <a:r>
+              <a:rPr lang="en-US"/>
+              <a:t>la normalisation du schéma, </a:t>
+            </a:r>
+            <a:r>
+              <a:rPr lang="en-US" dirty="0"/>
+              <a:t>sur la création d'une base en Code-First avec EF Core, sur l'interrogation en LINQ et </a:t>
+            </a:r>
+            <a:r>
+              <a:rPr lang="en-US"/>
+              <a:t>en t-SQL </a:t>
+            </a:r>
+            <a:r>
+              <a:rPr lang="en-US" dirty="0"/>
+              <a:t>avec l'optimisation </a:t>
+            </a:r>
+            <a:r>
+              <a:rPr lang="en-US"/>
+              <a:t>des requêtes. </a:t>
+            </a:r>
+            <a:r>
+              <a:rPr lang="en-US" dirty="0"/>
+              <a:t>Je vous remercie et je réponds à vos questions.</a:t>
+            </a:r>
           </a:p>
         </p:txBody>
       </p:sp>
@@ -954,9 +821,24 @@
           <a:p>
             <a:r>
               <a:rPr lang="en-US" dirty="0"/>
-              <a:t>NexaWorks édite des logiciels, chacun en plusieurs versions, compatibles avec différents systèmes d'exploitation. L'entreprise n'a aucun outil pour tracer les problèmes rencontrés. Ma mission : concevoir et créer cette base de données, la remplir, et fournir les requêtes pour l'interroger.</a:t>
-            </a:r>
-            <a:endParaRPr lang="en-US" dirty="0"/>
+              <a:t>NexaWorks édite des logiciels, chacun en plusieurs versions, compatibles avec différents systèmes d'exploitation. L'entreprise n'a aucun outil pour tracer les problèmes rencontrés</a:t>
+            </a:r>
+            <a:r>
+              <a:rPr lang="en-US"/>
+              <a:t>. Je dois </a:t>
+            </a:r>
+            <a:r>
+              <a:rPr lang="en-US" dirty="0"/>
+              <a:t>concevoir et </a:t>
+            </a:r>
+            <a:r>
+              <a:rPr lang="en-US"/>
+              <a:t>créer une </a:t>
+            </a:r>
+            <a:r>
+              <a:rPr lang="en-US" dirty="0"/>
+              <a:t>base de données, la remplir, et fournir les requêtes pour l'interroger.</a:t>
+            </a:r>
           </a:p>
         </p:txBody>
       </p:sp>
@@ -1041,10 +923,37 @@
           <a:lstStyle/>
           <a:p>
             <a:r>
+              <a:rPr lang="en-US"/>
+              <a:t>Je vous </a:t>
+            </a:r>
+            <a:r>
               <a:rPr lang="en-US" dirty="0"/>
-              <a:t>Point clé : je montre d'abord que ça marche. Je lance le programme en direct : il remplit la base puis exécute les 20 requêtes demandées. On voit tout de suite des résultats cohérents. Une fois rassurés que la solution fonctionne, je vais expliquer comment je l'ai construite.</a:t>
-            </a:r>
-            <a:endParaRPr lang="en-US" dirty="0"/>
+              <a:t>montre </a:t>
+            </a:r>
+            <a:r>
+              <a:rPr lang="en-US"/>
+              <a:t>d'abord le fonctionnement en démarrant le programme. </a:t>
+            </a:r>
+            <a:r>
+              <a:rPr lang="en-US" dirty="0"/>
+              <a:t>il remplit la </a:t>
+            </a:r>
+            <a:r>
+              <a:rPr lang="en-US"/>
+              <a:t>base (si elle est vide) puis </a:t>
+            </a:r>
+            <a:r>
+              <a:rPr lang="en-US" dirty="0"/>
+              <a:t>exécute les 20 requêtes demandées. On voit tout de </a:t>
+            </a:r>
+            <a:r>
+              <a:rPr lang="en-US"/>
+              <a:t>suite les résultats. J’explique ensuite comment elle a été construite</a:t>
+            </a:r>
+            <a:r>
+              <a:rPr lang="en-US" dirty="0"/>
+              <a:t>.</a:t>
+            </a:r>
           </a:p>
         </p:txBody>
       </p:sp>
@@ -1130,9 +1039,40 @@
           <a:p>
             <a:r>
               <a:rPr lang="en-US" dirty="0"/>
-              <a:t>Voici le modèle : six tables. Produit, Version qui appartient à un produit, OS, la table d'association Compatibilite qui relie versions et OS, Statut, et Ticket au centre. Un ticket concerne une compatibilité, donc une version sur un OS, et a un statut.</a:t>
-            </a:r>
-            <a:endParaRPr lang="en-US" dirty="0"/>
+              <a:t>Voici le </a:t>
+            </a:r>
+            <a:r>
+              <a:rPr lang="en-US"/>
+              <a:t>modèle compose de </a:t>
+            </a:r>
+            <a:r>
+              <a:rPr lang="en-US" dirty="0"/>
+              <a:t>six tables. Produit, Version qui appartient à un produit, OS, la table d'association Compatibilite qui </a:t>
+            </a:r>
+            <a:r>
+              <a:rPr lang="en-US"/>
+              <a:t>relie Versions </a:t>
+            </a:r>
+            <a:r>
+              <a:rPr lang="en-US" dirty="0"/>
+              <a:t>et OS, Statut</a:t>
+            </a:r>
+            <a:r>
+              <a:rPr lang="en-US"/>
+              <a:t>, et enfin la table Ticket qui est au centre </a:t>
+            </a:r>
+            <a:r>
+              <a:rPr lang="fr-FR"/>
+              <a:t>du modèle et qui référence les autres entités</a:t>
+            </a:r>
+            <a:r>
+              <a:rPr lang="en-US"/>
+              <a:t>. </a:t>
+            </a:r>
+            <a:r>
+              <a:rPr lang="en-US" dirty="0"/>
+              <a:t>Un ticket concerne une compatibilité, donc une version sur un OS, et a un statut.</a:t>
+            </a:r>
           </a:p>
         </p:txBody>
       </p:sp>
@@ -1217,8 +1157,30 @@
           <a:lstStyle/>
           <a:p>
             <a:r>
-              <a:rPr lang="en-US" dirty="0"/>
-              <a:t>Mes choix : la 3e forme normale, le produit se déduit du ticket via sa version, on ne le stocke pas. Une table d'association pour le plusieurs-à-plusieurs entre versions et OS, avec une contrainte d'unicité. Une seule clé étrangère sur le ticket, vers une compatibilité déjà validée, ce qui garantit un couple compatible. Et le numéro de version en texte car ce n'est pas un nombre.</a:t>
+              <a:rPr lang="en-US"/>
+              <a:t>Les choix de conception : J’utilise la 3e forme normale ou le produit se déduit du ticket via sa version. Une table d'association pour le plusieurs-à-plusieurs entre versions et OS, avec une contrainte d'unicité. Une clé étrangère sur le ticket </a:t>
+            </a:r>
+            <a:r>
+              <a:rPr lang="fr-FR" sz="1200" b="0" i="0" kern="1200">
+                <a:solidFill>
+                  <a:schemeClr val="tx1"/>
+                </a:solidFill>
+                <a:effectLst/>
+                <a:latin typeface="+mn-lt"/>
+                <a:ea typeface="+mn-ea"/>
+                <a:cs typeface="+mn-cs"/>
+              </a:rPr>
+              <a:t>référence un couple version + OS déjà déclaré, ce qui interdit les combinaisons impossibles.</a:t>
+            </a:r>
+            <a:r>
+              <a:rPr lang="en-US"/>
+              <a:t> </a:t>
+            </a:r>
+          </a:p>
+          <a:p>
+            <a:r>
+              <a:rPr lang="en-US"/>
+              <a:t>Le numéro de la table version est un champ texte (ce n'est pas un nombre).</a:t>
             </a:r>
             <a:endParaRPr lang="en-US" dirty="0"/>
           </a:p>
@@ -1306,7 +1268,27 @@
           <a:p>
             <a:r>
               <a:rPr lang="en-US" dirty="0"/>
-              <a:t>J'ai créé 25 tickets réalistes, en respectant la matrice de compatibilité : l'OS d'un ticket est toujours compatible avec sa version. Ils couvrent les 4 produits, les 12 versions, les 6 OS, au moins 3 de chaque, avec un mélange de 14 résolus et 11 en cours, comme demandé.</a:t>
+              <a:t>J'ai créé 25 tickets réalistes, en respectant la matrice de compatibilité : l'OS d'un ticket est toujours compatible avec sa version. Ils couvrent les 4 produits, les 12 versions, les 6 OS</a:t>
+            </a:r>
+            <a:r>
+              <a:rPr lang="en-US"/>
+              <a:t>, avec au </a:t>
+            </a:r>
+            <a:r>
+              <a:rPr lang="en-US" dirty="0"/>
+              <a:t>moins 3 </a:t>
+            </a:r>
+            <a:r>
+              <a:rPr lang="en-US"/>
+              <a:t>de chaque. Au total un </a:t>
+            </a:r>
+            <a:r>
+              <a:rPr lang="en-US" dirty="0"/>
+              <a:t>mélange de 14 résolus et 11 </a:t>
+            </a:r>
+            <a:r>
+              <a:rPr lang="en-US"/>
+              <a:t>en cours.</a:t>
             </a:r>
             <a:endParaRPr lang="en-US" dirty="0"/>
           </a:p>
@@ -1394,9 +1376,54 @@
           <a:p>
             <a:r>
               <a:rPr lang="en-US" dirty="0"/>
-              <a:t>Le premier ticket : les cours à 0,00 sur un PC français, à cause du format des nombres, virgule contre point. En forçant un format fixe, le programme lit correctement le point décimal : la solution répond directement au problème. Le second : le solde qui ne se rafraîchit pas ; on prévient l'affichage du changement, et il se met à jour automatiquement.</a:t>
-            </a:r>
-            <a:endParaRPr lang="en-US" dirty="0"/>
+              <a:t>Le premier ticket : les </a:t>
+            </a:r>
+            <a:r>
+              <a:rPr lang="en-US"/>
+              <a:t>cours de la bourse s’affichent à </a:t>
+            </a:r>
+            <a:r>
+              <a:rPr lang="en-US" dirty="0"/>
+              <a:t>0,00 sur un PC français, à cause du format des nombres</a:t>
+            </a:r>
+            <a:r>
+              <a:rPr lang="en-US"/>
+              <a:t>, la virgule au lieu du </a:t>
+            </a:r>
+            <a:r>
+              <a:rPr lang="en-US" dirty="0"/>
+              <a:t>point. En forçant un format fixe, le programme lit correctement le </a:t>
+            </a:r>
+            <a:r>
+              <a:rPr lang="en-US"/>
+              <a:t>point décimal. </a:t>
+            </a:r>
+          </a:p>
+          <a:p>
+            <a:r>
+              <a:rPr lang="en-US"/>
+              <a:t>Le </a:t>
+            </a:r>
+            <a:r>
+              <a:rPr lang="en-US" dirty="0"/>
+              <a:t>second : le solde qui ne se </a:t>
+            </a:r>
+            <a:r>
+              <a:rPr lang="en-US"/>
+              <a:t>rafraîchit pas à l’écran </a:t>
+            </a:r>
+            <a:r>
+              <a:rPr lang="en-US" dirty="0"/>
+              <a:t>; </a:t>
+            </a:r>
+            <a:r>
+              <a:rPr lang="en-US"/>
+              <a:t>on notifie l’interface à chaque changement de valeur, et l’écran </a:t>
+            </a:r>
+            <a:r>
+              <a:rPr lang="en-US" dirty="0"/>
+              <a:t>se met à jour automatiquement.</a:t>
+            </a:r>
           </a:p>
         </p:txBody>
       </p:sp>
@@ -1482,7 +1509,17 @@
           <a:p>
             <a:r>
               <a:rPr lang="en-US" dirty="0"/>
-              <a:t>J'ai choisi le Code-First : on écrit des classes C# pour chaque table, puis EF Core génère la base à partir d'une migration. C'est l'approche la plus courante en entreprise. En bonus, j'ai aussi écrit le schéma entièrement en SQL pur.</a:t>
+              <a:t>J'ai choisi le Code-First : on écrit des classes C# pour chaque table, puis EF Core génère la base à partir d'une migration. C'est l'approche la plus courante en entreprise</a:t>
+            </a:r>
+            <a:r>
+              <a:rPr lang="en-US"/>
+              <a:t>. </a:t>
+            </a:r>
+          </a:p>
+          <a:p>
+            <a:r>
+              <a:rPr lang="en-US"/>
+              <a:t>En complément, le même schéma est écrit entièrement en T-SQL avec SQL Server Management Studio.</a:t>
             </a:r>
             <a:endParaRPr lang="en-US" dirty="0"/>
           </a:p>
@@ -1570,7 +1607,41 @@
           <a:p>
             <a:r>
               <a:rPr lang="en-US" dirty="0"/>
-              <a:t>Pour remplir la base, un code crée les objets et les relie par leurs propriétés de navigation, puis un seul enregistrement envoie tout d'un coup dans une transaction. Au total : 4 produits, 6 OS, 2 statuts, 12 versions, 44 compatibilités et 25 tickets.</a:t>
+              <a:t>Pour remplir la base</a:t>
+            </a:r>
+            <a:r>
+              <a:rPr lang="en-US"/>
+              <a:t>, la classe DonneesInitiales.cs crée </a:t>
+            </a:r>
+            <a:r>
+              <a:rPr lang="en-US" dirty="0"/>
+              <a:t>les objets </a:t>
+            </a:r>
+            <a:r>
+              <a:rPr lang="en-US"/>
+              <a:t>et Seed.cs qui les relie à la BDD par </a:t>
+            </a:r>
+            <a:r>
+              <a:rPr lang="en-US" dirty="0"/>
+              <a:t>un </a:t>
+            </a:r>
+            <a:r>
+              <a:rPr lang="en-US"/>
+              <a:t>seul enregistrement ce qui </a:t>
+            </a:r>
+            <a:r>
+              <a:rPr lang="en-US" dirty="0"/>
+              <a:t>envoie tout d'un coup dans une transaction. Au total : 4 produits, 6 OS, 2 statuts, 12 versions, 44 compatibilités et 25 </a:t>
+            </a:r>
+            <a:r>
+              <a:rPr lang="en-US"/>
+              <a:t>tickets.</a:t>
+            </a:r>
+          </a:p>
+          <a:p>
+            <a:r>
+              <a:rPr lang="en-US"/>
+              <a:t>Fait également en T-SQL.</a:t>
             </a:r>
             <a:endParaRPr lang="en-US" dirty="0"/>
           </a:p>
@@ -1645,6 +1716,11 @@
 <file path=ppt/slideMasters/slideMaster1.xml><?xml version="1.0" encoding="utf-8"?>
 <p:sldMaster xmlns:a="http://schemas.openxmlformats.org/drawingml/2006/main" xmlns:r="http://schemas.openxmlformats.org/officeDocument/2006/relationships" xmlns:p="http://schemas.openxmlformats.org/presentationml/2006/main">
   <p:cSld>
+    <p:bg>
+      <p:bgRef idx="1001">
+        <a:schemeClr val="bg1"/>
+      </p:bgRef>
+    </p:bg>
     <p:spTree>
       <p:nvGrpSpPr>
         <p:cNvPr id="1" name=""/>
@@ -1927,6 +2003,7 @@
         <a:solidFill>
           <a:srgbClr val="0D1117"/>
         </a:solidFill>
+        <a:effectLst/>
       </p:bgPr>
     </p:bg>
     <p:spTree>
@@ -1969,7 +2046,7 @@
             <a:prstDash val="solid"/>
           </a:ln>
           <a:effectLst>
-            <a:outerShdw sx="100000" sy="100000" kx="0" ky="0" algn="bl" rotWithShape="0" blurRad="101600" dist="38100" dir="5400000">
+            <a:outerShdw blurRad="101600" dist="38100" dir="5400000" algn="bl" rotWithShape="0">
               <a:srgbClr val="000000">
                 <a:alpha val="45000"/>
               </a:srgbClr>
@@ -1979,14 +2056,14 @@
       </p:sp>
       <p:pic>
         <p:nvPicPr>
-          <p:cNvPr id="3" name="Image 0" descr="logo.png">    </p:cNvPr>
+          <p:cNvPr id="3" name="Image 0" descr="logo.png"/>
           <p:cNvPicPr>
             <a:picLocks noChangeAspect="1"/>
           </p:cNvPicPr>
           <p:nvPr/>
         </p:nvPicPr>
         <p:blipFill>
-          <a:blip r:embed="rId1"/>
+          <a:blip r:embed="rId3"/>
           <a:stretch>
             <a:fillRect/>
           </a:stretch>
@@ -2022,7 +2099,7 @@
           <a:bodyPr wrap="square" lIns="0" tIns="0" rIns="0" bIns="0" rtlCol="0" anchor="ctr"/>
           <a:lstStyle/>
           <a:p>
-            <a:pPr algn="ctr" indent="0" marL="0">
+            <a:pPr marL="0" indent="0" algn="ctr">
               <a:buNone/>
             </a:pPr>
             <a:r>
@@ -2061,7 +2138,7 @@
           <a:bodyPr wrap="square" lIns="0" tIns="0" rIns="0" bIns="0" rtlCol="0" anchor="ctr"/>
           <a:lstStyle/>
           <a:p>
-            <a:pPr algn="ctr" indent="0" marL="0">
+            <a:pPr marL="0" indent="0" algn="ctr">
               <a:buNone/>
             </a:pPr>
             <a:r>
@@ -2100,7 +2177,7 @@
           <a:bodyPr wrap="square" lIns="0" tIns="0" rIns="0" bIns="0" rtlCol="0" anchor="ctr"/>
           <a:lstStyle/>
           <a:p>
-            <a:pPr algn="ctr" indent="0" marL="0">
+            <a:pPr marL="0" indent="0" algn="ctr">
               <a:buNone/>
             </a:pPr>
             <a:r>
@@ -2139,7 +2216,7 @@
           <a:bodyPr wrap="square" lIns="0" tIns="0" rIns="0" bIns="0" rtlCol="0" anchor="ctr"/>
           <a:lstStyle/>
           <a:p>
-            <a:pPr algn="ctr" indent="0" marL="0">
+            <a:pPr marL="0" indent="0" algn="ctr">
               <a:buNone/>
             </a:pPr>
             <a:r>
@@ -2153,9 +2230,6 @@
               </a:rPr>
               <a:t>&gt; </a:t>
             </a:r>
-            <a:pPr algn="ctr" indent="0" marL="0">
-              <a:buNone/>
-            </a:pPr>
             <a:r>
               <a:rPr lang="en-US" sz="1500" dirty="0">
                 <a:solidFill>
@@ -2167,9 +2241,6 @@
               </a:rPr>
               <a:t>présenté par </a:t>
             </a:r>
-            <a:pPr algn="ctr" indent="0" marL="0">
-              <a:buNone/>
-            </a:pPr>
             <a:r>
               <a:rPr lang="en-US" sz="1500" dirty="0">
                 <a:solidFill>
@@ -2201,6 +2272,7 @@
         <a:solidFill>
           <a:srgbClr val="0D1117"/>
         </a:solidFill>
+        <a:effectLst/>
       </p:bgPr>
     </p:bg>
     <p:spTree>
@@ -2238,7 +2310,7 @@
           <a:bodyPr wrap="square" lIns="0" tIns="0" rIns="0" bIns="0" rtlCol="0" anchor="ctr"/>
           <a:lstStyle/>
           <a:p>
-            <a:pPr indent="0" marL="0">
+            <a:pPr marL="0" indent="0">
               <a:buNone/>
             </a:pPr>
             <a:r>
@@ -2277,7 +2349,7 @@
           <a:bodyPr wrap="square" lIns="0" tIns="0" rIns="0" bIns="0" rtlCol="0" anchor="ctr"/>
           <a:lstStyle/>
           <a:p>
-            <a:pPr indent="0" marL="0">
+            <a:pPr marL="0" indent="0">
               <a:buNone/>
             </a:pPr>
             <a:r>
@@ -2316,7 +2388,7 @@
           <a:bodyPr wrap="square" lIns="0" tIns="0" rIns="0" bIns="0" rtlCol="0" anchor="ctr"/>
           <a:lstStyle/>
           <a:p>
-            <a:pPr algn="ctr" indent="0" marL="0">
+            <a:pPr marL="0" indent="0" algn="ctr">
               <a:buNone/>
             </a:pPr>
             <a:r>
@@ -2330,9 +2402,6 @@
               </a:rPr>
               <a:t>20 demandes  </a:t>
             </a:r>
-            <a:pPr algn="ctr" indent="0" marL="0">
-              <a:buNone/>
-            </a:pPr>
             <a:r>
               <a:rPr lang="en-US" sz="2400" b="1" dirty="0">
                 <a:solidFill>
@@ -2344,9 +2413,6 @@
               </a:rPr>
               <a:t>=&gt;</a:t>
             </a:r>
-            <a:pPr algn="ctr" indent="0" marL="0">
-              <a:buNone/>
-            </a:pPr>
             <a:r>
               <a:rPr lang="en-US" sz="2400" b="1" dirty="0">
                 <a:solidFill>
@@ -2383,7 +2449,7 @@
           <a:bodyPr wrap="square" lIns="0" tIns="0" rIns="0" bIns="0" rtlCol="0" anchor="ctr"/>
           <a:lstStyle/>
           <a:p>
-            <a:pPr algn="ctr" indent="0" marL="0">
+            <a:pPr marL="0" indent="0" algn="ctr">
               <a:buNone/>
             </a:pPr>
             <a:r>
@@ -2427,7 +2493,7 @@
             <a:prstDash val="solid"/>
           </a:ln>
           <a:effectLst>
-            <a:outerShdw sx="100000" sy="100000" kx="0" ky="0" algn="bl" rotWithShape="0" blurRad="101600" dist="38100" dir="5400000">
+            <a:outerShdw blurRad="101600" dist="38100" dir="5400000" algn="bl" rotWithShape="0">
               <a:srgbClr val="000000">
                 <a:alpha val="45000"/>
               </a:srgbClr>
@@ -2476,7 +2542,7 @@
           <a:bodyPr wrap="square" lIns="0" tIns="0" rIns="0" bIns="0" rtlCol="0" anchor="ctr"/>
           <a:lstStyle/>
           <a:p>
-            <a:pPr algn="ctr" indent="0" marL="0">
+            <a:pPr marL="0" indent="0" algn="ctr">
               <a:buNone/>
             </a:pPr>
             <a:r>
@@ -2515,7 +2581,7 @@
           <a:bodyPr wrap="square" lIns="0" tIns="0" rIns="0" bIns="0" rtlCol="0" anchor="ctr"/>
           <a:lstStyle/>
           <a:p>
-            <a:pPr algn="ctr" indent="0" marL="0">
+            <a:pPr marL="0" indent="0" algn="ctr">
               <a:buNone/>
             </a:pPr>
             <a:r>
@@ -2559,7 +2625,7 @@
             <a:prstDash val="solid"/>
           </a:ln>
           <a:effectLst>
-            <a:outerShdw sx="100000" sy="100000" kx="0" ky="0" algn="bl" rotWithShape="0" blurRad="101600" dist="38100" dir="5400000">
+            <a:outerShdw blurRad="101600" dist="38100" dir="5400000" algn="bl" rotWithShape="0">
               <a:srgbClr val="000000">
                 <a:alpha val="45000"/>
               </a:srgbClr>
@@ -2608,7 +2674,7 @@
           <a:bodyPr wrap="square" lIns="0" tIns="0" rIns="0" bIns="0" rtlCol="0" anchor="ctr"/>
           <a:lstStyle/>
           <a:p>
-            <a:pPr algn="ctr" indent="0" marL="0">
+            <a:pPr marL="0" indent="0" algn="ctr">
               <a:buNone/>
             </a:pPr>
             <a:r>
@@ -2647,7 +2713,7 @@
           <a:bodyPr wrap="square" lIns="0" tIns="0" rIns="0" bIns="0" rtlCol="0" anchor="ctr"/>
           <a:lstStyle/>
           <a:p>
-            <a:pPr algn="ctr" indent="0" marL="0">
+            <a:pPr marL="0" indent="0" algn="ctr">
               <a:buNone/>
             </a:pPr>
             <a:r>
@@ -2691,7 +2757,7 @@
             <a:prstDash val="solid"/>
           </a:ln>
           <a:effectLst>
-            <a:outerShdw sx="100000" sy="100000" kx="0" ky="0" algn="bl" rotWithShape="0" blurRad="101600" dist="38100" dir="5400000">
+            <a:outerShdw blurRad="101600" dist="38100" dir="5400000" algn="bl" rotWithShape="0">
               <a:srgbClr val="000000">
                 <a:alpha val="45000"/>
               </a:srgbClr>
@@ -2740,7 +2806,7 @@
           <a:bodyPr wrap="square" lIns="0" tIns="0" rIns="0" bIns="0" rtlCol="0" anchor="ctr"/>
           <a:lstStyle/>
           <a:p>
-            <a:pPr algn="ctr" indent="0" marL="0">
+            <a:pPr marL="0" indent="0" algn="ctr">
               <a:buNone/>
             </a:pPr>
             <a:r>
@@ -2779,7 +2845,7 @@
           <a:bodyPr wrap="square" lIns="0" tIns="0" rIns="0" bIns="0" rtlCol="0" anchor="ctr"/>
           <a:lstStyle/>
           <a:p>
-            <a:pPr algn="ctr" indent="0" marL="0">
+            <a:pPr marL="0" indent="0" algn="ctr">
               <a:buNone/>
             </a:pPr>
             <a:r>
@@ -2823,7 +2889,7 @@
             <a:prstDash val="solid"/>
           </a:ln>
           <a:effectLst>
-            <a:outerShdw sx="100000" sy="100000" kx="0" ky="0" algn="bl" rotWithShape="0" blurRad="101600" dist="38100" dir="5400000">
+            <a:outerShdw blurRad="101600" dist="38100" dir="5400000" algn="bl" rotWithShape="0">
               <a:srgbClr val="000000">
                 <a:alpha val="45000"/>
               </a:srgbClr>
@@ -2872,7 +2938,7 @@
           <a:bodyPr wrap="square" lIns="0" tIns="0" rIns="0" bIns="0" rtlCol="0" anchor="ctr"/>
           <a:lstStyle/>
           <a:p>
-            <a:pPr algn="ctr" indent="0" marL="0">
+            <a:pPr marL="0" indent="0" algn="ctr">
               <a:buNone/>
             </a:pPr>
             <a:r>
@@ -2911,7 +2977,7 @@
           <a:bodyPr wrap="square" lIns="0" tIns="0" rIns="0" bIns="0" rtlCol="0" anchor="ctr"/>
           <a:lstStyle/>
           <a:p>
-            <a:pPr algn="ctr" indent="0" marL="0">
+            <a:pPr marL="0" indent="0" algn="ctr">
               <a:buNone/>
             </a:pPr>
             <a:r>
@@ -2955,7 +3021,7 @@
             <a:prstDash val="solid"/>
           </a:ln>
           <a:effectLst>
-            <a:outerShdw sx="100000" sy="100000" kx="0" ky="0" algn="bl" rotWithShape="0" blurRad="101600" dist="38100" dir="5400000">
+            <a:outerShdw blurRad="101600" dist="38100" dir="5400000" algn="bl" rotWithShape="0">
               <a:srgbClr val="000000">
                 <a:alpha val="45000"/>
               </a:srgbClr>
@@ -3004,7 +3070,7 @@
           <a:bodyPr wrap="square" lIns="0" tIns="0" rIns="0" bIns="0" rtlCol="0" anchor="ctr"/>
           <a:lstStyle/>
           <a:p>
-            <a:pPr algn="ctr" indent="0" marL="0">
+            <a:pPr marL="0" indent="0" algn="ctr">
               <a:buNone/>
             </a:pPr>
             <a:r>
@@ -3043,7 +3109,7 @@
           <a:bodyPr wrap="square" lIns="0" tIns="0" rIns="0" bIns="0" rtlCol="0" anchor="ctr"/>
           <a:lstStyle/>
           <a:p>
-            <a:pPr algn="ctr" indent="0" marL="0">
+            <a:pPr marL="0" indent="0" algn="ctr">
               <a:buNone/>
             </a:pPr>
             <a:r>
@@ -3082,7 +3148,7 @@
           <a:bodyPr wrap="square" lIns="0" tIns="0" rIns="0" bIns="0" rtlCol="0" anchor="ctr"/>
           <a:lstStyle/>
           <a:p>
-            <a:pPr algn="ctr" indent="0" marL="0">
+            <a:pPr marL="0" indent="0" algn="ctr">
               <a:buNone/>
             </a:pPr>
             <a:r>
@@ -3116,6 +3182,7 @@
         <a:solidFill>
           <a:srgbClr val="0D1117"/>
         </a:solidFill>
+        <a:effectLst/>
       </p:bgPr>
     </p:bg>
     <p:spTree>
@@ -3153,7 +3220,7 @@
           <a:bodyPr wrap="square" lIns="0" tIns="0" rIns="0" bIns="0" rtlCol="0" anchor="ctr"/>
           <a:lstStyle/>
           <a:p>
-            <a:pPr indent="0" marL="0">
+            <a:pPr marL="0" indent="0">
               <a:buNone/>
             </a:pPr>
             <a:r>
@@ -3192,7 +3259,7 @@
           <a:bodyPr wrap="square" lIns="0" tIns="0" rIns="0" bIns="0" rtlCol="0" anchor="ctr"/>
           <a:lstStyle/>
           <a:p>
-            <a:pPr indent="0" marL="0">
+            <a:pPr marL="0" indent="0">
               <a:buNone/>
             </a:pPr>
             <a:r>
@@ -3231,7 +3298,7 @@
           <a:bodyPr wrap="square" lIns="0" tIns="0" rIns="0" bIns="0" rtlCol="0" anchor="ctr"/>
           <a:lstStyle/>
           <a:p>
-            <a:pPr indent="0" marL="0">
+            <a:pPr marL="0" indent="0">
               <a:buNone/>
             </a:pPr>
             <a:r>
@@ -3275,7 +3342,7 @@
             <a:prstDash val="solid"/>
           </a:ln>
           <a:effectLst>
-            <a:outerShdw sx="100000" sy="100000" kx="0" ky="0" algn="bl" rotWithShape="0" blurRad="101600" dist="38100" dir="5400000">
+            <a:outerShdw blurRad="101600" dist="38100" dir="5400000" algn="bl" rotWithShape="0">
               <a:srgbClr val="000000">
                 <a:alpha val="45000"/>
               </a:srgbClr>
@@ -3304,7 +3371,7 @@
           <a:bodyPr wrap="square" lIns="0" tIns="0" rIns="0" bIns="0" rtlCol="0" anchor="t"/>
           <a:lstStyle/>
           <a:p>
-            <a:pPr indent="0" marL="0">
+            <a:pPr marL="0" indent="0">
               <a:lnSpc>
                 <a:spcPct val="118000"/>
               </a:lnSpc>
@@ -3324,7 +3391,7 @@
             <a:endParaRPr lang="en-US" sz="1250" dirty="0"/>
           </a:p>
           <a:p>
-            <a:pPr indent="0" marL="0">
+            <a:pPr marL="0" indent="0">
               <a:lnSpc>
                 <a:spcPct val="118000"/>
               </a:lnSpc>
@@ -3341,7 +3408,32 @@
               </a:rPr>
               <a:t>  .Where(t =&gt; </a:t>
             </a:r>
-            <a:pPr indent="0" marL="0">
+            <a:r>
+              <a:rPr lang="en-US" sz="1250" dirty="0">
+                <a:solidFill>
+                  <a:srgbClr val="D2A8FF"/>
+                </a:solidFill>
+                <a:latin typeface="Consolas" pitchFamily="34" charset="0"/>
+                <a:ea typeface="Consolas" pitchFamily="34" charset="-122"/>
+                <a:cs typeface="Consolas" pitchFamily="34" charset="-120"/>
+              </a:rPr>
+              <a:t>statut</a:t>
+            </a:r>
+            <a:r>
+              <a:rPr lang="en-US" sz="1250" dirty="0">
+                <a:solidFill>
+                  <a:srgbClr val="E6EDF3"/>
+                </a:solidFill>
+                <a:latin typeface="Consolas" pitchFamily="34" charset="0"/>
+                <a:ea typeface="Consolas" pitchFamily="34" charset="-122"/>
+                <a:cs typeface="Consolas" pitchFamily="34" charset="-120"/>
+              </a:rPr>
+              <a:t> == null</a:t>
+            </a:r>
+            <a:endParaRPr lang="en-US" sz="1250" dirty="0"/>
+          </a:p>
+          <a:p>
+            <a:pPr marL="0" indent="0">
               <a:lnSpc>
                 <a:spcPct val="118000"/>
               </a:lnSpc>
@@ -3350,6 +3442,17 @@
             <a:r>
               <a:rPr lang="en-US" sz="1250" dirty="0">
                 <a:solidFill>
+                  <a:srgbClr val="E6EDF3"/>
+                </a:solidFill>
+                <a:latin typeface="Consolas" pitchFamily="34" charset="0"/>
+                <a:ea typeface="Consolas" pitchFamily="34" charset="-122"/>
+                <a:cs typeface="Consolas" pitchFamily="34" charset="-120"/>
+              </a:rPr>
+              <a:t>     || t.Statut.Nom == </a:t>
+            </a:r>
+            <a:r>
+              <a:rPr lang="en-US" sz="1250" dirty="0">
+                <a:solidFill>
                   <a:srgbClr val="D2A8FF"/>
                 </a:solidFill>
                 <a:latin typeface="Consolas" pitchFamily="34" charset="0"/>
@@ -3358,7 +3461,21 @@
               </a:rPr>
               <a:t>statut</a:t>
             </a:r>
-            <a:pPr indent="0" marL="0">
+            <a:r>
+              <a:rPr lang="en-US" sz="1250" dirty="0">
+                <a:solidFill>
+                  <a:srgbClr val="E6EDF3"/>
+                </a:solidFill>
+                <a:latin typeface="Consolas" pitchFamily="34" charset="0"/>
+                <a:ea typeface="Consolas" pitchFamily="34" charset="-122"/>
+                <a:cs typeface="Consolas" pitchFamily="34" charset="-120"/>
+              </a:rPr>
+              <a:t>)</a:t>
+            </a:r>
+            <a:endParaRPr lang="en-US" sz="1250" dirty="0"/>
+          </a:p>
+          <a:p>
+            <a:pPr marL="0" indent="0">
               <a:lnSpc>
                 <a:spcPct val="118000"/>
               </a:lnSpc>
@@ -3373,12 +3490,12 @@
                 <a:ea typeface="Consolas" pitchFamily="34" charset="-122"/>
                 <a:cs typeface="Consolas" pitchFamily="34" charset="-120"/>
               </a:rPr>
-              <a:t> == null</a:t>
+              <a:t>  .Where(t =&gt; t.Probleme</a:t>
             </a:r>
             <a:endParaRPr lang="en-US" sz="1250" dirty="0"/>
           </a:p>
           <a:p>
-            <a:pPr indent="0" marL="0">
+            <a:pPr marL="0" indent="0">
               <a:lnSpc>
                 <a:spcPct val="118000"/>
               </a:lnSpc>
@@ -3393,9 +3510,34 @@
                 <a:ea typeface="Consolas" pitchFamily="34" charset="-122"/>
                 <a:cs typeface="Consolas" pitchFamily="34" charset="-120"/>
               </a:rPr>
-              <a:t>     || t.Statut.Nom == </a:t>
-            </a:r>
-            <a:pPr indent="0" marL="0">
+              <a:t>     .Contains(</a:t>
+            </a:r>
+            <a:r>
+              <a:rPr lang="en-US" sz="1250" dirty="0">
+                <a:solidFill>
+                  <a:srgbClr val="D2A8FF"/>
+                </a:solidFill>
+                <a:latin typeface="Consolas" pitchFamily="34" charset="0"/>
+                <a:ea typeface="Consolas" pitchFamily="34" charset="-122"/>
+                <a:cs typeface="Consolas" pitchFamily="34" charset="-120"/>
+              </a:rPr>
+              <a:t>mot</a:t>
+            </a:r>
+            <a:r>
+              <a:rPr lang="en-US" sz="1250" dirty="0">
+                <a:solidFill>
+                  <a:srgbClr val="E6EDF3"/>
+                </a:solidFill>
+                <a:latin typeface="Consolas" pitchFamily="34" charset="0"/>
+                <a:ea typeface="Consolas" pitchFamily="34" charset="-122"/>
+                <a:cs typeface="Consolas" pitchFamily="34" charset="-120"/>
+              </a:rPr>
+              <a:t>))</a:t>
+            </a:r>
+            <a:endParaRPr lang="en-US" sz="1250" dirty="0"/>
+          </a:p>
+          <a:p>
+            <a:pPr marL="0" indent="0">
               <a:lnSpc>
                 <a:spcPct val="118000"/>
               </a:lnSpc>
@@ -3404,117 +3546,6 @@
             <a:r>
               <a:rPr lang="en-US" sz="1250" dirty="0">
                 <a:solidFill>
-                  <a:srgbClr val="D2A8FF"/>
-                </a:solidFill>
-                <a:latin typeface="Consolas" pitchFamily="34" charset="0"/>
-                <a:ea typeface="Consolas" pitchFamily="34" charset="-122"/>
-                <a:cs typeface="Consolas" pitchFamily="34" charset="-120"/>
-              </a:rPr>
-              <a:t>statut</a:t>
-            </a:r>
-            <a:pPr indent="0" marL="0">
-              <a:lnSpc>
-                <a:spcPct val="118000"/>
-              </a:lnSpc>
-              <a:buNone/>
-            </a:pPr>
-            <a:r>
-              <a:rPr lang="en-US" sz="1250" dirty="0">
-                <a:solidFill>
-                  <a:srgbClr val="E6EDF3"/>
-                </a:solidFill>
-                <a:latin typeface="Consolas" pitchFamily="34" charset="0"/>
-                <a:ea typeface="Consolas" pitchFamily="34" charset="-122"/>
-                <a:cs typeface="Consolas" pitchFamily="34" charset="-120"/>
-              </a:rPr>
-              <a:t>)</a:t>
-            </a:r>
-            <a:endParaRPr lang="en-US" sz="1250" dirty="0"/>
-          </a:p>
-          <a:p>
-            <a:pPr indent="0" marL="0">
-              <a:lnSpc>
-                <a:spcPct val="118000"/>
-              </a:lnSpc>
-              <a:buNone/>
-            </a:pPr>
-            <a:r>
-              <a:rPr lang="en-US" sz="1250" dirty="0">
-                <a:solidFill>
-                  <a:srgbClr val="E6EDF3"/>
-                </a:solidFill>
-                <a:latin typeface="Consolas" pitchFamily="34" charset="0"/>
-                <a:ea typeface="Consolas" pitchFamily="34" charset="-122"/>
-                <a:cs typeface="Consolas" pitchFamily="34" charset="-120"/>
-              </a:rPr>
-              <a:t>  .Where(t =&gt; t.Probleme</a:t>
-            </a:r>
-            <a:endParaRPr lang="en-US" sz="1250" dirty="0"/>
-          </a:p>
-          <a:p>
-            <a:pPr indent="0" marL="0">
-              <a:lnSpc>
-                <a:spcPct val="118000"/>
-              </a:lnSpc>
-              <a:buNone/>
-            </a:pPr>
-            <a:r>
-              <a:rPr lang="en-US" sz="1250" dirty="0">
-                <a:solidFill>
-                  <a:srgbClr val="E6EDF3"/>
-                </a:solidFill>
-                <a:latin typeface="Consolas" pitchFamily="34" charset="0"/>
-                <a:ea typeface="Consolas" pitchFamily="34" charset="-122"/>
-                <a:cs typeface="Consolas" pitchFamily="34" charset="-120"/>
-              </a:rPr>
-              <a:t>     .Contains(</a:t>
-            </a:r>
-            <a:pPr indent="0" marL="0">
-              <a:lnSpc>
-                <a:spcPct val="118000"/>
-              </a:lnSpc>
-              <a:buNone/>
-            </a:pPr>
-            <a:r>
-              <a:rPr lang="en-US" sz="1250" dirty="0">
-                <a:solidFill>
-                  <a:srgbClr val="D2A8FF"/>
-                </a:solidFill>
-                <a:latin typeface="Consolas" pitchFamily="34" charset="0"/>
-                <a:ea typeface="Consolas" pitchFamily="34" charset="-122"/>
-                <a:cs typeface="Consolas" pitchFamily="34" charset="-120"/>
-              </a:rPr>
-              <a:t>mot</a:t>
-            </a:r>
-            <a:pPr indent="0" marL="0">
-              <a:lnSpc>
-                <a:spcPct val="118000"/>
-              </a:lnSpc>
-              <a:buNone/>
-            </a:pPr>
-            <a:r>
-              <a:rPr lang="en-US" sz="1250" dirty="0">
-                <a:solidFill>
-                  <a:srgbClr val="E6EDF3"/>
-                </a:solidFill>
-                <a:latin typeface="Consolas" pitchFamily="34" charset="0"/>
-                <a:ea typeface="Consolas" pitchFamily="34" charset="-122"/>
-                <a:cs typeface="Consolas" pitchFamily="34" charset="-120"/>
-              </a:rPr>
-              <a:t>))</a:t>
-            </a:r>
-            <a:endParaRPr lang="en-US" sz="1250" dirty="0"/>
-          </a:p>
-          <a:p>
-            <a:pPr indent="0" marL="0">
-              <a:lnSpc>
-                <a:spcPct val="118000"/>
-              </a:lnSpc>
-              <a:buNone/>
-            </a:pPr>
-            <a:r>
-              <a:rPr lang="en-US" sz="1250" dirty="0">
-                <a:solidFill>
                   <a:srgbClr val="E6EDF3"/>
                 </a:solidFill>
                 <a:latin typeface="Consolas" pitchFamily="34" charset="0"/>
@@ -3548,7 +3579,7 @@
           <a:bodyPr wrap="square" lIns="0" tIns="0" rIns="0" bIns="0" rtlCol="0" anchor="ctr"/>
           <a:lstStyle/>
           <a:p>
-            <a:pPr indent="0" marL="0">
+            <a:pPr marL="0" indent="0">
               <a:buNone/>
             </a:pPr>
             <a:r>
@@ -3592,7 +3623,7 @@
             <a:prstDash val="solid"/>
           </a:ln>
           <a:effectLst>
-            <a:outerShdw sx="100000" sy="100000" kx="0" ky="0" algn="bl" rotWithShape="0" blurRad="101600" dist="38100" dir="5400000">
+            <a:outerShdw blurRad="101600" dist="38100" dir="5400000" algn="bl" rotWithShape="0">
               <a:srgbClr val="000000">
                 <a:alpha val="45000"/>
               </a:srgbClr>
@@ -3621,7 +3652,7 @@
           <a:bodyPr wrap="square" lIns="0" tIns="0" rIns="0" bIns="0" rtlCol="0" anchor="t"/>
           <a:lstStyle/>
           <a:p>
-            <a:pPr indent="0" marL="0">
+            <a:pPr marL="0" indent="0">
               <a:lnSpc>
                 <a:spcPct val="118000"/>
               </a:lnSpc>
@@ -3638,7 +3669,21 @@
               </a:rPr>
               <a:t>CREATE PROCEDURE </a:t>
             </a:r>
-            <a:pPr indent="0" marL="0">
+            <a:r>
+              <a:rPr lang="en-US" sz="1250" dirty="0">
+                <a:solidFill>
+                  <a:srgbClr val="79C0FF"/>
+                </a:solidFill>
+                <a:latin typeface="Consolas" pitchFamily="34" charset="0"/>
+                <a:ea typeface="Consolas" pitchFamily="34" charset="-122"/>
+                <a:cs typeface="Consolas" pitchFamily="34" charset="-120"/>
+              </a:rPr>
+              <a:t>ObtenirTickets</a:t>
+            </a:r>
+            <a:endParaRPr lang="en-US" sz="1250" dirty="0"/>
+          </a:p>
+          <a:p>
+            <a:pPr marL="0" indent="0">
               <a:lnSpc>
                 <a:spcPct val="118000"/>
               </a:lnSpc>
@@ -3647,18 +3692,40 @@
             <a:r>
               <a:rPr lang="en-US" sz="1250" dirty="0">
                 <a:solidFill>
-                  <a:srgbClr val="79C0FF"/>
-                </a:solidFill>
-                <a:latin typeface="Consolas" pitchFamily="34" charset="0"/>
-                <a:ea typeface="Consolas" pitchFamily="34" charset="-122"/>
-                <a:cs typeface="Consolas" pitchFamily="34" charset="-120"/>
-              </a:rPr>
-              <a:t>ObtenirTickets</a:t>
+                  <a:srgbClr val="E6EDF3"/>
+                </a:solidFill>
+                <a:latin typeface="Consolas" pitchFamily="34" charset="0"/>
+                <a:ea typeface="Consolas" pitchFamily="34" charset="-122"/>
+                <a:cs typeface="Consolas" pitchFamily="34" charset="-120"/>
+              </a:rPr>
+              <a:t>  @Statut NVARCHAR(50) = </a:t>
+            </a:r>
+            <a:r>
+              <a:rPr lang="en-US" sz="1250" dirty="0">
+                <a:solidFill>
+                  <a:srgbClr val="FF7B72"/>
+                </a:solidFill>
+                <a:latin typeface="Consolas" pitchFamily="34" charset="0"/>
+                <a:ea typeface="Consolas" pitchFamily="34" charset="-122"/>
+                <a:cs typeface="Consolas" pitchFamily="34" charset="-120"/>
+              </a:rPr>
+              <a:t>NULL</a:t>
+            </a:r>
+            <a:r>
+              <a:rPr lang="en-US" sz="1250" dirty="0">
+                <a:solidFill>
+                  <a:srgbClr val="E6EDF3"/>
+                </a:solidFill>
+                <a:latin typeface="Consolas" pitchFamily="34" charset="0"/>
+                <a:ea typeface="Consolas" pitchFamily="34" charset="-122"/>
+                <a:cs typeface="Consolas" pitchFamily="34" charset="-120"/>
+              </a:rPr>
+              <a:t>, ...</a:t>
             </a:r>
             <a:endParaRPr lang="en-US" sz="1250" dirty="0"/>
           </a:p>
           <a:p>
-            <a:pPr indent="0" marL="0">
+            <a:pPr marL="0" indent="0">
               <a:lnSpc>
                 <a:spcPct val="118000"/>
               </a:lnSpc>
@@ -3667,15 +3734,18 @@
             <a:r>
               <a:rPr lang="en-US" sz="1250" dirty="0">
                 <a:solidFill>
-                  <a:srgbClr val="E6EDF3"/>
-                </a:solidFill>
-                <a:latin typeface="Consolas" pitchFamily="34" charset="0"/>
-                <a:ea typeface="Consolas" pitchFamily="34" charset="-122"/>
-                <a:cs typeface="Consolas" pitchFamily="34" charset="-120"/>
-              </a:rPr>
-              <a:t>  @Statut NVARCHAR(50) = </a:t>
-            </a:r>
-            <a:pPr indent="0" marL="0">
+                  <a:srgbClr val="8B949E"/>
+                </a:solidFill>
+                <a:latin typeface="Consolas" pitchFamily="34" charset="0"/>
+                <a:ea typeface="Consolas" pitchFamily="34" charset="-122"/>
+                <a:cs typeface="Consolas" pitchFamily="34" charset="-120"/>
+              </a:rPr>
+              <a:t>...</a:t>
+            </a:r>
+            <a:endParaRPr lang="en-US" sz="1250" dirty="0"/>
+          </a:p>
+          <a:p>
+            <a:pPr marL="0" indent="0">
               <a:lnSpc>
                 <a:spcPct val="118000"/>
               </a:lnSpc>
@@ -3684,15 +3754,29 @@
             <a:r>
               <a:rPr lang="en-US" sz="1250" dirty="0">
                 <a:solidFill>
+                  <a:srgbClr val="E6EDF3"/>
+                </a:solidFill>
+                <a:latin typeface="Consolas" pitchFamily="34" charset="0"/>
+                <a:ea typeface="Consolas" pitchFamily="34" charset="-122"/>
+                <a:cs typeface="Consolas" pitchFamily="34" charset="-120"/>
+              </a:rPr>
+              <a:t>WHERE (</a:t>
+            </a:r>
+            <a:r>
+              <a:rPr lang="en-US" sz="1250" dirty="0">
+                <a:solidFill>
                   <a:srgbClr val="FF7B72"/>
                 </a:solidFill>
                 <a:latin typeface="Consolas" pitchFamily="34" charset="0"/>
                 <a:ea typeface="Consolas" pitchFamily="34" charset="-122"/>
                 <a:cs typeface="Consolas" pitchFamily="34" charset="-120"/>
               </a:rPr>
-              <a:t>NULL</a:t>
-            </a:r>
-            <a:pPr indent="0" marL="0">
+              <a:t>@Statut IS NULL</a:t>
+            </a:r>
+            <a:endParaRPr lang="en-US" sz="1250" dirty="0"/>
+          </a:p>
+          <a:p>
+            <a:pPr marL="0" indent="0">
               <a:lnSpc>
                 <a:spcPct val="118000"/>
               </a:lnSpc>
@@ -3707,12 +3791,12 @@
                 <a:ea typeface="Consolas" pitchFamily="34" charset="-122"/>
                 <a:cs typeface="Consolas" pitchFamily="34" charset="-120"/>
               </a:rPr>
-              <a:t>, ...</a:t>
+              <a:t>       OR s.Nom = @Statut)</a:t>
             </a:r>
             <a:endParaRPr lang="en-US" sz="1250" dirty="0"/>
           </a:p>
           <a:p>
-            <a:pPr indent="0" marL="0">
+            <a:pPr marL="0" indent="0">
               <a:lnSpc>
                 <a:spcPct val="118000"/>
               </a:lnSpc>
@@ -3721,83 +3805,6 @@
             <a:r>
               <a:rPr lang="en-US" sz="1250" dirty="0">
                 <a:solidFill>
-                  <a:srgbClr val="8B949E"/>
-                </a:solidFill>
-                <a:latin typeface="Consolas" pitchFamily="34" charset="0"/>
-                <a:ea typeface="Consolas" pitchFamily="34" charset="-122"/>
-                <a:cs typeface="Consolas" pitchFamily="34" charset="-120"/>
-              </a:rPr>
-              <a:t>...</a:t>
-            </a:r>
-            <a:endParaRPr lang="en-US" sz="1250" dirty="0"/>
-          </a:p>
-          <a:p>
-            <a:pPr indent="0" marL="0">
-              <a:lnSpc>
-                <a:spcPct val="118000"/>
-              </a:lnSpc>
-              <a:buNone/>
-            </a:pPr>
-            <a:r>
-              <a:rPr lang="en-US" sz="1250" dirty="0">
-                <a:solidFill>
-                  <a:srgbClr val="E6EDF3"/>
-                </a:solidFill>
-                <a:latin typeface="Consolas" pitchFamily="34" charset="0"/>
-                <a:ea typeface="Consolas" pitchFamily="34" charset="-122"/>
-                <a:cs typeface="Consolas" pitchFamily="34" charset="-120"/>
-              </a:rPr>
-              <a:t>WHERE (</a:t>
-            </a:r>
-            <a:pPr indent="0" marL="0">
-              <a:lnSpc>
-                <a:spcPct val="118000"/>
-              </a:lnSpc>
-              <a:buNone/>
-            </a:pPr>
-            <a:r>
-              <a:rPr lang="en-US" sz="1250" dirty="0">
-                <a:solidFill>
-                  <a:srgbClr val="FF7B72"/>
-                </a:solidFill>
-                <a:latin typeface="Consolas" pitchFamily="34" charset="0"/>
-                <a:ea typeface="Consolas" pitchFamily="34" charset="-122"/>
-                <a:cs typeface="Consolas" pitchFamily="34" charset="-120"/>
-              </a:rPr>
-              <a:t>@Statut IS NULL</a:t>
-            </a:r>
-            <a:endParaRPr lang="en-US" sz="1250" dirty="0"/>
-          </a:p>
-          <a:p>
-            <a:pPr indent="0" marL="0">
-              <a:lnSpc>
-                <a:spcPct val="118000"/>
-              </a:lnSpc>
-              <a:buNone/>
-            </a:pPr>
-            <a:r>
-              <a:rPr lang="en-US" sz="1250" dirty="0">
-                <a:solidFill>
-                  <a:srgbClr val="E6EDF3"/>
-                </a:solidFill>
-                <a:latin typeface="Consolas" pitchFamily="34" charset="0"/>
-                <a:ea typeface="Consolas" pitchFamily="34" charset="-122"/>
-                <a:cs typeface="Consolas" pitchFamily="34" charset="-120"/>
-              </a:rPr>
-              <a:t>       OR s.Nom = @Statut)</a:t>
-            </a:r>
-            <a:endParaRPr lang="en-US" sz="1250" dirty="0"/>
-          </a:p>
-          <a:p>
-            <a:pPr indent="0" marL="0">
-              <a:lnSpc>
-                <a:spcPct val="118000"/>
-              </a:lnSpc>
-              <a:buNone/>
-            </a:pPr>
-            <a:r>
-              <a:rPr lang="en-US" sz="1250" dirty="0">
-                <a:solidFill>
                   <a:srgbClr val="E6EDF3"/>
                 </a:solidFill>
                 <a:latin typeface="Consolas" pitchFamily="34" charset="0"/>
@@ -3851,7 +3858,7 @@
           <a:bodyPr wrap="square" lIns="0" tIns="0" rIns="0" bIns="0" rtlCol="0" anchor="t"/>
           <a:lstStyle/>
           <a:p>
-            <a:pPr indent="0" marL="0">
+            <a:pPr marL="0" indent="0">
               <a:buNone/>
             </a:pPr>
             <a:r>
@@ -3865,9 +3872,6 @@
               </a:rPr>
               <a:t>Mêmes résultats  </a:t>
             </a:r>
-            <a:pPr indent="0" marL="0">
-              <a:buNone/>
-            </a:pPr>
             <a:r>
               <a:rPr lang="en-US" sz="1450" dirty="0">
                 <a:solidFill>
@@ -3899,6 +3903,7 @@
         <a:solidFill>
           <a:srgbClr val="0D1117"/>
         </a:solidFill>
+        <a:effectLst/>
       </p:bgPr>
     </p:bg>
     <p:spTree>
@@ -3936,7 +3941,7 @@
           <a:bodyPr wrap="square" lIns="0" tIns="0" rIns="0" bIns="0" rtlCol="0" anchor="ctr"/>
           <a:lstStyle/>
           <a:p>
-            <a:pPr indent="0" marL="0">
+            <a:pPr marL="0" indent="0">
               <a:buNone/>
             </a:pPr>
             <a:r>
@@ -3975,7 +3980,7 @@
           <a:bodyPr wrap="square" lIns="0" tIns="0" rIns="0" bIns="0" rtlCol="0" anchor="ctr"/>
           <a:lstStyle/>
           <a:p>
-            <a:pPr indent="0" marL="0">
+            <a:pPr marL="0" indent="0">
               <a:buNone/>
             </a:pPr>
             <a:r>
@@ -4019,7 +4024,7 @@
             <a:prstDash val="solid"/>
           </a:ln>
           <a:effectLst>
-            <a:outerShdw sx="100000" sy="100000" kx="0" ky="0" algn="bl" rotWithShape="0" blurRad="101600" dist="38100" dir="5400000">
+            <a:outerShdw blurRad="101600" dist="38100" dir="5400000" algn="bl" rotWithShape="0">
               <a:srgbClr val="000000">
                 <a:alpha val="45000"/>
               </a:srgbClr>
@@ -4048,7 +4053,7 @@
           <a:bodyPr wrap="square" lIns="0" tIns="0" rIns="0" bIns="0" rtlCol="0" anchor="ctr"/>
           <a:lstStyle/>
           <a:p>
-            <a:pPr indent="0" marL="0">
+            <a:pPr marL="0" indent="0">
               <a:buNone/>
             </a:pPr>
             <a:r>
@@ -4087,7 +4092,7 @@
           <a:bodyPr wrap="square" lIns="0" tIns="0" rIns="0" bIns="0" rtlCol="0" anchor="t"/>
           <a:lstStyle/>
           <a:p>
-            <a:pPr indent="0" marL="0">
+            <a:pPr marL="0" indent="0">
               <a:lnSpc>
                 <a:spcPct val="115000"/>
               </a:lnSpc>
@@ -4104,12 +4109,6 @@
               </a:rPr>
               <a:t>Un fichier Excel documente les 20 demandes : </a:t>
             </a:r>
-            <a:pPr indent="0" marL="0">
-              <a:lnSpc>
-                <a:spcPct val="115000"/>
-              </a:lnSpc>
-              <a:buNone/>
-            </a:pPr>
             <a:r>
               <a:rPr lang="en-US" sz="1450" b="1" dirty="0">
                 <a:solidFill>
@@ -4121,12 +4120,6 @@
               </a:rPr>
               <a:t>but, paramètres, résultat escompté et résultat obtenu </a:t>
             </a:r>
-            <a:pPr indent="0" marL="0">
-              <a:lnSpc>
-                <a:spcPct val="115000"/>
-              </a:lnSpc>
-              <a:buNone/>
-            </a:pPr>
             <a:r>
               <a:rPr lang="en-US" sz="1450" dirty="0">
                 <a:solidFill>
@@ -4168,7 +4161,7 @@
             <a:prstDash val="solid"/>
           </a:ln>
           <a:effectLst>
-            <a:outerShdw sx="100000" sy="100000" kx="0" ky="0" algn="bl" rotWithShape="0" blurRad="101600" dist="38100" dir="5400000">
+            <a:outerShdw blurRad="101600" dist="38100" dir="5400000" algn="bl" rotWithShape="0">
               <a:srgbClr val="000000">
                 <a:alpha val="45000"/>
               </a:srgbClr>
@@ -4197,7 +4190,7 @@
           <a:bodyPr wrap="square" lIns="0" tIns="0" rIns="0" bIns="0" rtlCol="0" anchor="ctr"/>
           <a:lstStyle/>
           <a:p>
-            <a:pPr indent="0" marL="0">
+            <a:pPr marL="0" indent="0">
               <a:buNone/>
             </a:pPr>
             <a:r>
@@ -4236,7 +4229,7 @@
           <a:bodyPr wrap="square" lIns="0" tIns="0" rIns="0" bIns="0" rtlCol="0" anchor="t"/>
           <a:lstStyle/>
           <a:p>
-            <a:pPr indent="0" marL="0">
+            <a:pPr marL="0" indent="0">
               <a:lnSpc>
                 <a:spcPct val="115000"/>
               </a:lnSpc>
@@ -4253,12 +4246,6 @@
               </a:rPr>
               <a:t>Une copie intégrale de la base au format </a:t>
             </a:r>
-            <a:pPr indent="0" marL="0">
-              <a:lnSpc>
-                <a:spcPct val="115000"/>
-              </a:lnSpc>
-              <a:buNone/>
-            </a:pPr>
             <a:r>
               <a:rPr lang="en-US" sz="1450" b="1" dirty="0">
                 <a:solidFill>
@@ -4270,12 +4257,6 @@
               </a:rPr>
               <a:t>.bak</a:t>
             </a:r>
-            <a:pPr indent="0" marL="0">
-              <a:lnSpc>
-                <a:spcPct val="115000"/>
-              </a:lnSpc>
-              <a:buNone/>
-            </a:pPr>
             <a:r>
               <a:rPr lang="en-US" sz="1450" dirty="0">
                 <a:solidFill>
@@ -4307,6 +4288,7 @@
         <a:solidFill>
           <a:srgbClr val="0D1117"/>
         </a:solidFill>
+        <a:effectLst/>
       </p:bgPr>
     </p:bg>
     <p:spTree>
@@ -4344,7 +4326,7 @@
           <a:bodyPr wrap="square" lIns="0" tIns="0" rIns="0" bIns="0" rtlCol="0" anchor="ctr"/>
           <a:lstStyle/>
           <a:p>
-            <a:pPr indent="0" marL="0">
+            <a:pPr marL="0" indent="0">
               <a:buNone/>
             </a:pPr>
             <a:r>
@@ -4383,7 +4365,7 @@
           <a:bodyPr wrap="square" lIns="0" tIns="0" rIns="0" bIns="0" rtlCol="0" anchor="ctr"/>
           <a:lstStyle/>
           <a:p>
-            <a:pPr indent="0" marL="0">
+            <a:pPr marL="0" indent="0">
               <a:buNone/>
             </a:pPr>
             <a:r>
@@ -4442,7 +4424,7 @@
           <a:bodyPr wrap="square" lIns="0" tIns="0" rIns="0" bIns="0" rtlCol="0" anchor="t"/>
           <a:lstStyle/>
           <a:p>
-            <a:pPr indent="0" marL="0">
+            <a:pPr marL="0" indent="0">
               <a:buNone/>
             </a:pPr>
             <a:r>
@@ -4456,9 +4438,6 @@
               </a:rPr>
               <a:t>Modélisation  </a:t>
             </a:r>
-            <a:pPr indent="0" marL="0">
-              <a:buNone/>
-            </a:pPr>
             <a:r>
               <a:rPr lang="en-US" sz="1600" dirty="0">
                 <a:solidFill>
@@ -4515,7 +4494,7 @@
           <a:bodyPr wrap="square" lIns="0" tIns="0" rIns="0" bIns="0" rtlCol="0" anchor="t"/>
           <a:lstStyle/>
           <a:p>
-            <a:pPr indent="0" marL="0">
+            <a:pPr marL="0" indent="0">
               <a:buNone/>
             </a:pPr>
             <a:r>
@@ -4529,9 +4508,6 @@
               </a:rPr>
               <a:t>Code-First avec EF Core  </a:t>
             </a:r>
-            <a:pPr indent="0" marL="0">
-              <a:buNone/>
-            </a:pPr>
             <a:r>
               <a:rPr lang="en-US" sz="1600" dirty="0">
                 <a:solidFill>
@@ -4588,7 +4564,7 @@
           <a:bodyPr wrap="square" lIns="0" tIns="0" rIns="0" bIns="0" rtlCol="0" anchor="t"/>
           <a:lstStyle/>
           <a:p>
-            <a:pPr indent="0" marL="0">
+            <a:pPr marL="0" indent="0">
               <a:buNone/>
             </a:pPr>
             <a:r>
@@ -4602,9 +4578,6 @@
               </a:rPr>
               <a:t>Interrogation  </a:t>
             </a:r>
-            <a:pPr indent="0" marL="0">
-              <a:buNone/>
-            </a:pPr>
             <a:r>
               <a:rPr lang="en-US" sz="1600" dirty="0">
                 <a:solidFill>
@@ -4614,7 +4587,29 @@
                 <a:ea typeface="Calibri" pitchFamily="34" charset="-122"/>
                 <a:cs typeface="Calibri" pitchFamily="34" charset="-120"/>
               </a:rPr>
-              <a:t>LINQ et SQL, et l'art d'optimiser des requêtes.</a:t>
+              <a:t>LINQ et SQL, </a:t>
+            </a:r>
+            <a:r>
+              <a:rPr lang="en-US" sz="1600">
+                <a:solidFill>
+                  <a:srgbClr val="8B949E"/>
+                </a:solidFill>
+                <a:latin typeface="Calibri" pitchFamily="34" charset="0"/>
+                <a:ea typeface="Calibri" pitchFamily="34" charset="-122"/>
+                <a:cs typeface="Calibri" pitchFamily="34" charset="-120"/>
+              </a:rPr>
+              <a:t>et l'optimisation </a:t>
+            </a:r>
+            <a:r>
+              <a:rPr lang="en-US" sz="1600" dirty="0">
+                <a:solidFill>
+                  <a:srgbClr val="8B949E"/>
+                </a:solidFill>
+                <a:latin typeface="Calibri" pitchFamily="34" charset="0"/>
+                <a:ea typeface="Calibri" pitchFamily="34" charset="-122"/>
+                <a:cs typeface="Calibri" pitchFamily="34" charset="-120"/>
+              </a:rPr>
+              <a:t>des requêtes.</a:t>
             </a:r>
             <a:endParaRPr lang="en-US" sz="1600" dirty="0"/>
           </a:p>
@@ -4661,11 +4656,11 @@
           <a:bodyPr wrap="square" lIns="0" tIns="0" rIns="0" bIns="0" rtlCol="0" anchor="t"/>
           <a:lstStyle/>
           <a:p>
-            <a:pPr indent="0" marL="0">
-              <a:buNone/>
-            </a:pPr>
-            <a:r>
-              <a:rPr lang="en-US" sz="1600" b="1" dirty="0">
+            <a:pPr marL="0" indent="0">
+              <a:buNone/>
+            </a:pPr>
+            <a:r>
+              <a:rPr lang="en-US" sz="1600" b="1">
                 <a:solidFill>
                   <a:srgbClr val="E6EDF3"/>
                 </a:solidFill>
@@ -4673,11 +4668,8 @@
                 <a:ea typeface="Calibri" pitchFamily="34" charset="-122"/>
                 <a:cs typeface="Calibri" pitchFamily="34" charset="-120"/>
               </a:rPr>
-              <a:t>Rigueur des livrables  </a:t>
-            </a:r>
-            <a:pPr indent="0" marL="0">
-              <a:buNone/>
-            </a:pPr>
+              <a:t>Livrables  </a:t>
+            </a:r>
             <a:r>
               <a:rPr lang="en-US" sz="1600" dirty="0">
                 <a:solidFill>
@@ -4714,7 +4706,7 @@
           <a:bodyPr wrap="square" lIns="0" tIns="0" rIns="0" bIns="0" rtlCol="0" anchor="ctr"/>
           <a:lstStyle/>
           <a:p>
-            <a:pPr algn="ctr" indent="0" marL="0">
+            <a:pPr marL="0" indent="0" algn="ctr">
               <a:buNone/>
             </a:pPr>
             <a:r>
@@ -4728,9 +4720,6 @@
               </a:rPr>
               <a:t>&gt; </a:t>
             </a:r>
-            <a:pPr algn="ctr" indent="0" marL="0">
-              <a:buNone/>
-            </a:pPr>
             <a:r>
               <a:rPr lang="en-US" sz="2000" b="1" dirty="0">
                 <a:solidFill>
@@ -4762,6 +4751,7 @@
         <a:solidFill>
           <a:srgbClr val="0D1117"/>
         </a:solidFill>
+        <a:effectLst/>
       </p:bgPr>
     </p:bg>
     <p:spTree>
@@ -4799,7 +4789,7 @@
           <a:bodyPr wrap="square" lIns="0" tIns="0" rIns="0" bIns="0" rtlCol="0" anchor="ctr"/>
           <a:lstStyle/>
           <a:p>
-            <a:pPr indent="0" marL="0">
+            <a:pPr marL="0" indent="0">
               <a:buNone/>
             </a:pPr>
             <a:r>
@@ -4838,7 +4828,7 @@
           <a:bodyPr wrap="square" lIns="0" tIns="0" rIns="0" bIns="0" rtlCol="0" anchor="ctr"/>
           <a:lstStyle/>
           <a:p>
-            <a:pPr indent="0" marL="0">
+            <a:pPr marL="0" indent="0">
               <a:buNone/>
             </a:pPr>
             <a:r>
@@ -4882,7 +4872,7 @@
             <a:prstDash val="solid"/>
           </a:ln>
           <a:effectLst>
-            <a:outerShdw sx="100000" sy="100000" kx="0" ky="0" algn="bl" rotWithShape="0" blurRad="101600" dist="38100" dir="5400000">
+            <a:outerShdw blurRad="101600" dist="38100" dir="5400000" algn="bl" rotWithShape="0">
               <a:srgbClr val="000000">
                 <a:alpha val="45000"/>
               </a:srgbClr>
@@ -4911,7 +4901,7 @@
           <a:bodyPr wrap="square" lIns="0" tIns="0" rIns="0" bIns="0" rtlCol="0" anchor="ctr"/>
           <a:lstStyle/>
           <a:p>
-            <a:pPr indent="0" marL="0">
+            <a:pPr marL="0" indent="0">
               <a:buNone/>
             </a:pPr>
             <a:r>
@@ -4970,7 +4960,7 @@
           <a:bodyPr wrap="square" lIns="0" tIns="0" rIns="0" bIns="0" rtlCol="0" anchor="t"/>
           <a:lstStyle/>
           <a:p>
-            <a:pPr indent="0" marL="0">
+            <a:pPr marL="0" indent="0">
               <a:buNone/>
             </a:pPr>
             <a:r>
@@ -4984,9 +4974,6 @@
               </a:rPr>
               <a:t>Des produits  </a:t>
             </a:r>
-            <a:pPr indent="0" marL="0">
-              <a:buNone/>
-            </a:pPr>
             <a:r>
               <a:rPr lang="en-US" sz="1450" dirty="0">
                 <a:solidFill>
@@ -5043,7 +5030,7 @@
           <a:bodyPr wrap="square" lIns="0" tIns="0" rIns="0" bIns="0" rtlCol="0" anchor="t"/>
           <a:lstStyle/>
           <a:p>
-            <a:pPr indent="0" marL="0">
+            <a:pPr marL="0" indent="0">
               <a:buNone/>
             </a:pPr>
             <a:r>
@@ -5057,9 +5044,6 @@
               </a:rPr>
               <a:t>Des systèmes d'exploitation  </a:t>
             </a:r>
-            <a:pPr indent="0" marL="0">
-              <a:buNone/>
-            </a:pPr>
             <a:r>
               <a:rPr lang="en-US" sz="1450" dirty="0">
                 <a:solidFill>
@@ -5116,7 +5100,7 @@
           <a:bodyPr wrap="square" lIns="0" tIns="0" rIns="0" bIns="0" rtlCol="0" anchor="t"/>
           <a:lstStyle/>
           <a:p>
-            <a:pPr indent="0" marL="0">
+            <a:pPr marL="0" indent="0">
               <a:buNone/>
             </a:pPr>
             <a:r>
@@ -5130,9 +5114,6 @@
               </a:rPr>
               <a:t>Des problèmes  </a:t>
             </a:r>
-            <a:pPr indent="0" marL="0">
-              <a:buNone/>
-            </a:pPr>
             <a:r>
               <a:rPr lang="en-US" sz="1450" dirty="0">
                 <a:solidFill>
@@ -5189,7 +5170,7 @@
           <a:bodyPr wrap="square" lIns="0" tIns="0" rIns="0" bIns="0" rtlCol="0" anchor="t"/>
           <a:lstStyle/>
           <a:p>
-            <a:pPr indent="0" marL="0">
+            <a:pPr marL="0" indent="0">
               <a:buNone/>
             </a:pPr>
             <a:r>
@@ -5203,9 +5184,6 @@
               </a:rPr>
               <a:t>Aucun outil existant  </a:t>
             </a:r>
-            <a:pPr indent="0" marL="0">
-              <a:buNone/>
-            </a:pPr>
             <a:r>
               <a:rPr lang="en-US" sz="1450" dirty="0">
                 <a:solidFill>
@@ -5247,7 +5225,7 @@
             <a:prstDash val="solid"/>
           </a:ln>
           <a:effectLst>
-            <a:outerShdw sx="100000" sy="100000" kx="0" ky="0" algn="bl" rotWithShape="0" blurRad="101600" dist="38100" dir="5400000">
+            <a:outerShdw blurRad="101600" dist="38100" dir="5400000" algn="bl" rotWithShape="0">
               <a:srgbClr val="000000">
                 <a:alpha val="45000"/>
               </a:srgbClr>
@@ -5276,7 +5254,7 @@
           <a:bodyPr wrap="square" lIns="0" tIns="0" rIns="0" bIns="0" rtlCol="0" anchor="ctr"/>
           <a:lstStyle/>
           <a:p>
-            <a:pPr indent="0" marL="0">
+            <a:pPr marL="0" indent="0">
               <a:buNone/>
             </a:pPr>
             <a:r>
@@ -5315,7 +5293,7 @@
           <a:bodyPr wrap="square" lIns="0" tIns="0" rIns="0" bIns="0" rtlCol="0" anchor="t"/>
           <a:lstStyle/>
           <a:p>
-            <a:pPr indent="0" marL="0">
+            <a:pPr marL="0" indent="0">
               <a:lnSpc>
                 <a:spcPct val="120000"/>
               </a:lnSpc>
@@ -5357,7 +5335,7 @@
           <a:bodyPr wrap="square" lIns="0" tIns="0" rIns="0" bIns="0" rtlCol="0" anchor="t"/>
           <a:lstStyle/>
           <a:p>
-            <a:pPr indent="0" marL="0">
+            <a:pPr marL="0" indent="0">
               <a:buNone/>
             </a:pPr>
             <a:r>
@@ -5391,6 +5369,7 @@
         <a:solidFill>
           <a:srgbClr val="0D1117"/>
         </a:solidFill>
+        <a:effectLst/>
       </p:bgPr>
     </p:bg>
     <p:spTree>
@@ -5428,7 +5407,7 @@
           <a:bodyPr wrap="square" lIns="0" tIns="0" rIns="0" bIns="0" rtlCol="0" anchor="ctr"/>
           <a:lstStyle/>
           <a:p>
-            <a:pPr indent="0" marL="0">
+            <a:pPr marL="0" indent="0">
               <a:buNone/>
             </a:pPr>
             <a:r>
@@ -5467,7 +5446,7 @@
           <a:bodyPr wrap="square" lIns="0" tIns="0" rIns="0" bIns="0" rtlCol="0" anchor="ctr"/>
           <a:lstStyle/>
           <a:p>
-            <a:pPr indent="0" marL="0">
+            <a:pPr marL="0" indent="0">
               <a:buNone/>
             </a:pPr>
             <a:r>
@@ -5506,7 +5485,7 @@
           <a:bodyPr wrap="square" lIns="0" tIns="0" rIns="0" bIns="0" rtlCol="0" anchor="ctr"/>
           <a:lstStyle/>
           <a:p>
-            <a:pPr indent="0" marL="0">
+            <a:pPr marL="0" indent="0">
               <a:buNone/>
             </a:pPr>
             <a:r>
@@ -5545,7 +5524,7 @@
           <a:bodyPr wrap="square" lIns="0" tIns="0" rIns="0" bIns="0" rtlCol="0" anchor="ctr"/>
           <a:lstStyle/>
           <a:p>
-            <a:pPr algn="ctr" indent="0" marL="0">
+            <a:pPr marL="0" indent="0" algn="ctr">
               <a:buNone/>
             </a:pPr>
             <a:r>
@@ -5584,7 +5563,7 @@
           <a:bodyPr wrap="square" lIns="0" tIns="0" rIns="0" bIns="0" rtlCol="0" anchor="ctr"/>
           <a:lstStyle/>
           <a:p>
-            <a:pPr algn="ctr" indent="0" marL="0">
+            <a:pPr marL="0" indent="0" algn="ctr">
               <a:buNone/>
             </a:pPr>
             <a:r>
@@ -5623,7 +5602,7 @@
           <a:bodyPr wrap="square" lIns="0" tIns="0" rIns="0" bIns="0" rtlCol="0" anchor="ctr"/>
           <a:lstStyle/>
           <a:p>
-            <a:pPr algn="ctr" indent="0" marL="0">
+            <a:pPr marL="0" indent="0" algn="ctr">
               <a:buNone/>
             </a:pPr>
             <a:r>
@@ -5662,7 +5641,7 @@
           <a:bodyPr wrap="square" lIns="0" tIns="0" rIns="0" bIns="0" rtlCol="0" anchor="ctr"/>
           <a:lstStyle/>
           <a:p>
-            <a:pPr algn="ctr" indent="0" marL="0">
+            <a:pPr marL="0" indent="0" algn="ctr">
               <a:buNone/>
             </a:pPr>
             <a:r>
@@ -5701,7 +5680,7 @@
           <a:bodyPr wrap="square" lIns="0" tIns="0" rIns="0" bIns="0" rtlCol="0" anchor="ctr"/>
           <a:lstStyle/>
           <a:p>
-            <a:pPr algn="ctr" indent="0" marL="0">
+            <a:pPr marL="0" indent="0" algn="ctr">
               <a:buNone/>
             </a:pPr>
             <a:r>
@@ -5740,7 +5719,7 @@
           <a:bodyPr wrap="square" lIns="0" tIns="0" rIns="0" bIns="0" rtlCol="0" anchor="ctr"/>
           <a:lstStyle/>
           <a:p>
-            <a:pPr algn="ctr" indent="0" marL="0">
+            <a:pPr marL="0" indent="0" algn="ctr">
               <a:buNone/>
             </a:pPr>
             <a:r>
@@ -5784,7 +5763,7 @@
             <a:prstDash val="solid"/>
           </a:ln>
           <a:effectLst>
-            <a:outerShdw sx="100000" sy="100000" kx="0" ky="0" algn="bl" rotWithShape="0" blurRad="101600" dist="38100" dir="5400000">
+            <a:outerShdw blurRad="101600" dist="38100" dir="5400000" algn="bl" rotWithShape="0">
               <a:srgbClr val="000000">
                 <a:alpha val="45000"/>
               </a:srgbClr>
@@ -5813,7 +5792,7 @@
           <a:bodyPr wrap="square" lIns="0" tIns="0" rIns="0" bIns="0" rtlCol="0" anchor="t"/>
           <a:lstStyle/>
           <a:p>
-            <a:pPr indent="0" marL="0">
+            <a:pPr marL="0" indent="0">
               <a:lnSpc>
                 <a:spcPct val="118000"/>
               </a:lnSpc>
@@ -5833,7 +5812,7 @@
             <a:endParaRPr lang="en-US" sz="1400" dirty="0"/>
           </a:p>
           <a:p>
-            <a:pPr indent="0" marL="0">
+            <a:pPr marL="0" indent="0">
               <a:lnSpc>
                 <a:spcPct val="118000"/>
               </a:lnSpc>
@@ -5850,7 +5829,21 @@
               </a:rPr>
               <a:t>En cours (tous les produits)          : </a:t>
             </a:r>
-            <a:pPr indent="0" marL="0">
+            <a:r>
+              <a:rPr lang="en-US" sz="1400" dirty="0">
+                <a:solidFill>
+                  <a:srgbClr val="E3B341"/>
+                </a:solidFill>
+                <a:latin typeface="Consolas" pitchFamily="34" charset="0"/>
+                <a:ea typeface="Consolas" pitchFamily="34" charset="-122"/>
+                <a:cs typeface="Consolas" pitchFamily="34" charset="-120"/>
+              </a:rPr>
+              <a:t>11 tickets</a:t>
+            </a:r>
+            <a:endParaRPr lang="en-US" sz="1400" dirty="0"/>
+          </a:p>
+          <a:p>
+            <a:pPr marL="0" indent="0">
               <a:lnSpc>
                 <a:spcPct val="118000"/>
               </a:lnSpc>
@@ -5859,18 +5852,29 @@
             <a:r>
               <a:rPr lang="en-US" sz="1400" dirty="0">
                 <a:solidFill>
+                  <a:srgbClr val="E6EDF3"/>
+                </a:solidFill>
+                <a:latin typeface="Consolas" pitchFamily="34" charset="0"/>
+                <a:ea typeface="Consolas" pitchFamily="34" charset="-122"/>
+                <a:cs typeface="Consolas" pitchFamily="34" charset="-120"/>
+              </a:rPr>
+              <a:t>Résolus, Trader en Herbe, version 1.2 : </a:t>
+            </a:r>
+            <a:r>
+              <a:rPr lang="en-US" sz="1400" dirty="0">
+                <a:solidFill>
                   <a:srgbClr val="E3B341"/>
                 </a:solidFill>
                 <a:latin typeface="Consolas" pitchFamily="34" charset="0"/>
                 <a:ea typeface="Consolas" pitchFamily="34" charset="-122"/>
                 <a:cs typeface="Consolas" pitchFamily="34" charset="-120"/>
               </a:rPr>
-              <a:t>11 tickets</a:t>
+              <a:t> 2 tickets</a:t>
             </a:r>
             <a:endParaRPr lang="en-US" sz="1400" dirty="0"/>
           </a:p>
           <a:p>
-            <a:pPr indent="0" marL="0">
+            <a:pPr marL="0" indent="0">
               <a:lnSpc>
                 <a:spcPct val="118000"/>
               </a:lnSpc>
@@ -5885,9 +5889,34 @@
                 <a:ea typeface="Consolas" pitchFamily="34" charset="-122"/>
                 <a:cs typeface="Consolas" pitchFamily="34" charset="-120"/>
               </a:rPr>
-              <a:t>Résolus, Trader en Herbe, version 1.2 : </a:t>
-            </a:r>
-            <a:pPr indent="0" marL="0">
+              <a:t>Contenant le mot-clé </a:t>
+            </a:r>
+            <a:r>
+              <a:rPr lang="en-US" sz="1400" dirty="0">
+                <a:solidFill>
+                  <a:srgbClr val="79C0FF"/>
+                </a:solidFill>
+                <a:latin typeface="Consolas" pitchFamily="34" charset="0"/>
+                <a:ea typeface="Consolas" pitchFamily="34" charset="-122"/>
+                <a:cs typeface="Consolas" pitchFamily="34" charset="-120"/>
+              </a:rPr>
+              <a:t>"batterie"</a:t>
+            </a:r>
+            <a:r>
+              <a:rPr lang="en-US" sz="1400" dirty="0">
+                <a:solidFill>
+                  <a:srgbClr val="E3B341"/>
+                </a:solidFill>
+                <a:latin typeface="Consolas" pitchFamily="34" charset="0"/>
+                <a:ea typeface="Consolas" pitchFamily="34" charset="-122"/>
+                <a:cs typeface="Consolas" pitchFamily="34" charset="-120"/>
+              </a:rPr>
+              <a:t>          :  1 ticket</a:t>
+            </a:r>
+            <a:endParaRPr lang="en-US" sz="1400" dirty="0"/>
+          </a:p>
+          <a:p>
+            <a:pPr marL="0" indent="0">
               <a:lnSpc>
                 <a:spcPct val="118000"/>
               </a:lnSpc>
@@ -5896,109 +5925,29 @@
             <a:r>
               <a:rPr lang="en-US" sz="1400" dirty="0">
                 <a:solidFill>
+                  <a:srgbClr val="E6EDF3"/>
+                </a:solidFill>
+                <a:latin typeface="Consolas" pitchFamily="34" charset="0"/>
+                <a:ea typeface="Consolas" pitchFamily="34" charset="-122"/>
+                <a:cs typeface="Consolas" pitchFamily="34" charset="-120"/>
+              </a:rPr>
+              <a:t>Rencontrés en juin 2026               : </a:t>
+            </a:r>
+            <a:r>
+              <a:rPr lang="en-US" sz="1400" dirty="0">
+                <a:solidFill>
                   <a:srgbClr val="E3B341"/>
                 </a:solidFill>
                 <a:latin typeface="Consolas" pitchFamily="34" charset="0"/>
                 <a:ea typeface="Consolas" pitchFamily="34" charset="-122"/>
                 <a:cs typeface="Consolas" pitchFamily="34" charset="-120"/>
               </a:rPr>
-              <a:t> 2 tickets</a:t>
+              <a:t> 5 tickets</a:t>
             </a:r>
             <a:endParaRPr lang="en-US" sz="1400" dirty="0"/>
           </a:p>
           <a:p>
-            <a:pPr indent="0" marL="0">
-              <a:lnSpc>
-                <a:spcPct val="118000"/>
-              </a:lnSpc>
-              <a:buNone/>
-            </a:pPr>
-            <a:r>
-              <a:rPr lang="en-US" sz="1400" dirty="0">
-                <a:solidFill>
-                  <a:srgbClr val="E6EDF3"/>
-                </a:solidFill>
-                <a:latin typeface="Consolas" pitchFamily="34" charset="0"/>
-                <a:ea typeface="Consolas" pitchFamily="34" charset="-122"/>
-                <a:cs typeface="Consolas" pitchFamily="34" charset="-120"/>
-              </a:rPr>
-              <a:t>Contenant le mot-clé </a:t>
-            </a:r>
-            <a:pPr indent="0" marL="0">
-              <a:lnSpc>
-                <a:spcPct val="118000"/>
-              </a:lnSpc>
-              <a:buNone/>
-            </a:pPr>
-            <a:r>
-              <a:rPr lang="en-US" sz="1400" dirty="0">
-                <a:solidFill>
-                  <a:srgbClr val="79C0FF"/>
-                </a:solidFill>
-                <a:latin typeface="Consolas" pitchFamily="34" charset="0"/>
-                <a:ea typeface="Consolas" pitchFamily="34" charset="-122"/>
-                <a:cs typeface="Consolas" pitchFamily="34" charset="-120"/>
-              </a:rPr>
-              <a:t>"batterie"</a:t>
-            </a:r>
-            <a:pPr indent="0" marL="0">
-              <a:lnSpc>
-                <a:spcPct val="118000"/>
-              </a:lnSpc>
-              <a:buNone/>
-            </a:pPr>
-            <a:r>
-              <a:rPr lang="en-US" sz="1400" dirty="0">
-                <a:solidFill>
-                  <a:srgbClr val="E3B341"/>
-                </a:solidFill>
-                <a:latin typeface="Consolas" pitchFamily="34" charset="0"/>
-                <a:ea typeface="Consolas" pitchFamily="34" charset="-122"/>
-                <a:cs typeface="Consolas" pitchFamily="34" charset="-120"/>
-              </a:rPr>
-              <a:t>          :  1 ticket</a:t>
-            </a:r>
-            <a:endParaRPr lang="en-US" sz="1400" dirty="0"/>
-          </a:p>
-          <a:p>
-            <a:pPr indent="0" marL="0">
-              <a:lnSpc>
-                <a:spcPct val="118000"/>
-              </a:lnSpc>
-              <a:buNone/>
-            </a:pPr>
-            <a:r>
-              <a:rPr lang="en-US" sz="1400" dirty="0">
-                <a:solidFill>
-                  <a:srgbClr val="E6EDF3"/>
-                </a:solidFill>
-                <a:latin typeface="Consolas" pitchFamily="34" charset="0"/>
-                <a:ea typeface="Consolas" pitchFamily="34" charset="-122"/>
-                <a:cs typeface="Consolas" pitchFamily="34" charset="-120"/>
-              </a:rPr>
-              <a:t>Rencontrés en juin 2026               : </a:t>
-            </a:r>
-            <a:pPr indent="0" marL="0">
-              <a:lnSpc>
-                <a:spcPct val="118000"/>
-              </a:lnSpc>
-              <a:buNone/>
-            </a:pPr>
-            <a:r>
-              <a:rPr lang="en-US" sz="1400" dirty="0">
-                <a:solidFill>
-                  <a:srgbClr val="E3B341"/>
-                </a:solidFill>
-                <a:latin typeface="Consolas" pitchFamily="34" charset="0"/>
-                <a:ea typeface="Consolas" pitchFamily="34" charset="-122"/>
-                <a:cs typeface="Consolas" pitchFamily="34" charset="-120"/>
-              </a:rPr>
-              <a:t> 5 tickets</a:t>
-            </a:r>
-            <a:endParaRPr lang="en-US" sz="1400" dirty="0"/>
-          </a:p>
-          <a:p>
-            <a:pPr indent="0" marL="0">
+            <a:pPr marL="0" indent="0">
               <a:lnSpc>
                 <a:spcPct val="118000"/>
               </a:lnSpc>
@@ -6035,6 +5984,7 @@
         <a:solidFill>
           <a:srgbClr val="0D1117"/>
         </a:solidFill>
+        <a:effectLst/>
       </p:bgPr>
     </p:bg>
     <p:spTree>
@@ -6072,7 +6022,7 @@
           <a:bodyPr wrap="square" lIns="0" tIns="0" rIns="0" bIns="0" rtlCol="0" anchor="ctr"/>
           <a:lstStyle/>
           <a:p>
-            <a:pPr indent="0" marL="0">
+            <a:pPr marL="0" indent="0">
               <a:buNone/>
             </a:pPr>
             <a:r>
@@ -6111,7 +6061,7 @@
           <a:bodyPr wrap="square" lIns="0" tIns="0" rIns="0" bIns="0" rtlCol="0" anchor="ctr"/>
           <a:lstStyle/>
           <a:p>
-            <a:pPr indent="0" marL="0">
+            <a:pPr marL="0" indent="0">
               <a:buNone/>
             </a:pPr>
             <a:r>
@@ -6155,7 +6105,7 @@
             <a:prstDash val="solid"/>
           </a:ln>
           <a:effectLst>
-            <a:outerShdw sx="100000" sy="100000" kx="0" ky="0" algn="bl" rotWithShape="0" blurRad="101600" dist="38100" dir="5400000">
+            <a:outerShdw blurRad="101600" dist="38100" dir="5400000" algn="bl" rotWithShape="0">
               <a:srgbClr val="000000">
                 <a:alpha val="45000"/>
               </a:srgbClr>
@@ -6165,14 +6115,14 @@
       </p:sp>
       <p:pic>
         <p:nvPicPr>
-          <p:cNvPr id="5" name="Image 0" descr="schema_crop.png">    </p:cNvPr>
+          <p:cNvPr id="5" name="Image 0" descr="schema_crop.png"/>
           <p:cNvPicPr>
             <a:picLocks noChangeAspect="1"/>
           </p:cNvPicPr>
           <p:nvPr/>
         </p:nvPicPr>
         <p:blipFill>
-          <a:blip r:embed="rId1"/>
+          <a:blip r:embed="rId3"/>
           <a:stretch>
             <a:fillRect/>
           </a:stretch>
@@ -6208,7 +6158,7 @@
           <a:bodyPr wrap="square" lIns="0" tIns="0" rIns="0" bIns="0" rtlCol="0" anchor="ctr"/>
           <a:lstStyle/>
           <a:p>
-            <a:pPr algn="ctr" indent="0" marL="0">
+            <a:pPr marL="0" indent="0" algn="ctr">
               <a:buNone/>
             </a:pPr>
             <a:r>
@@ -6242,6 +6192,7 @@
         <a:solidFill>
           <a:srgbClr val="0D1117"/>
         </a:solidFill>
+        <a:effectLst/>
       </p:bgPr>
     </p:bg>
     <p:spTree>
@@ -6279,7 +6230,7 @@
           <a:bodyPr wrap="square" lIns="0" tIns="0" rIns="0" bIns="0" rtlCol="0" anchor="ctr"/>
           <a:lstStyle/>
           <a:p>
-            <a:pPr indent="0" marL="0">
+            <a:pPr marL="0" indent="0">
               <a:buNone/>
             </a:pPr>
             <a:r>
@@ -6318,7 +6269,7 @@
           <a:bodyPr wrap="square" lIns="0" tIns="0" rIns="0" bIns="0" rtlCol="0" anchor="ctr"/>
           <a:lstStyle/>
           <a:p>
-            <a:pPr indent="0" marL="0">
+            <a:pPr marL="0" indent="0">
               <a:buNone/>
             </a:pPr>
             <a:r>
@@ -6377,7 +6328,7 @@
           <a:bodyPr wrap="square" lIns="0" tIns="0" rIns="0" bIns="0" rtlCol="0" anchor="t"/>
           <a:lstStyle/>
           <a:p>
-            <a:pPr indent="0" marL="0">
+            <a:pPr marL="0" indent="0">
               <a:buNone/>
             </a:pPr>
             <a:r>
@@ -6391,9 +6342,6 @@
               </a:rPr>
               <a:t>3e forme normale  </a:t>
             </a:r>
-            <a:pPr indent="0" marL="0">
-              <a:buNone/>
-            </a:pPr>
             <a:r>
               <a:rPr lang="en-US" sz="1450" dirty="0">
                 <a:solidFill>
@@ -6450,7 +6398,7 @@
           <a:bodyPr wrap="square" lIns="0" tIns="0" rIns="0" bIns="0" rtlCol="0" anchor="t"/>
           <a:lstStyle/>
           <a:p>
-            <a:pPr indent="0" marL="0">
+            <a:pPr marL="0" indent="0">
               <a:buNone/>
             </a:pPr>
             <a:r>
@@ -6464,9 +6412,6 @@
               </a:rPr>
               <a:t>Table d'association Compatibilite  </a:t>
             </a:r>
-            <a:pPr indent="0" marL="0">
-              <a:buNone/>
-            </a:pPr>
             <a:r>
               <a:rPr lang="en-US" sz="1450" dirty="0">
                 <a:solidFill>
@@ -6523,7 +6468,7 @@
           <a:bodyPr wrap="square" lIns="0" tIns="0" rIns="0" bIns="0" rtlCol="0" anchor="t"/>
           <a:lstStyle/>
           <a:p>
-            <a:pPr indent="0" marL="0">
+            <a:pPr marL="0" indent="0">
               <a:buNone/>
             </a:pPr>
             <a:r>
@@ -6537,9 +6482,6 @@
               </a:rPr>
               <a:t>Contrainte d'unicité  </a:t>
             </a:r>
-            <a:pPr indent="0" marL="0">
-              <a:buNone/>
-            </a:pPr>
             <a:r>
               <a:rPr lang="en-US" sz="1450" dirty="0">
                 <a:solidFill>
@@ -6596,11 +6538,11 @@
           <a:bodyPr wrap="square" lIns="0" tIns="0" rIns="0" bIns="0" rtlCol="0" anchor="t"/>
           <a:lstStyle/>
           <a:p>
-            <a:pPr indent="0" marL="0">
-              <a:buNone/>
-            </a:pPr>
-            <a:r>
-              <a:rPr lang="en-US" sz="1450" b="1" dirty="0">
+            <a:pPr marL="0" indent="0">
+              <a:buNone/>
+            </a:pPr>
+            <a:r>
+              <a:rPr lang="en-US" sz="1450" b="1">
                 <a:solidFill>
                   <a:srgbClr val="E6EDF3"/>
                 </a:solidFill>
@@ -6608,13 +6550,10 @@
                 <a:ea typeface="Calibri" pitchFamily="34" charset="-122"/>
                 <a:cs typeface="Calibri" pitchFamily="34" charset="-120"/>
               </a:rPr>
-              <a:t>Une seule clé étrangère sur le ticket  </a:t>
-            </a:r>
-            <a:pPr indent="0" marL="0">
-              <a:buNone/>
-            </a:pPr>
-            <a:r>
-              <a:rPr lang="en-US" sz="1450" dirty="0">
+              <a:t>Le ticket pointe vers une compatibilité valide</a:t>
+            </a:r>
+            <a:r>
+              <a:rPr lang="en-US" sz="1450" b="1">
                 <a:solidFill>
                   <a:srgbClr val="8B949E"/>
                 </a:solidFill>
@@ -6622,7 +6561,7 @@
                 <a:ea typeface="Calibri" pitchFamily="34" charset="-122"/>
                 <a:cs typeface="Calibri" pitchFamily="34" charset="-120"/>
               </a:rPr>
-              <a:t>vers une compatibilité déjà validée.</a:t>
+              <a:t>Un couple Version + OS déjà validé, donc jamais incohérent.</a:t>
             </a:r>
             <a:endParaRPr lang="en-US" sz="1450" dirty="0"/>
           </a:p>
@@ -6669,11 +6608,11 @@
           <a:bodyPr wrap="square" lIns="0" tIns="0" rIns="0" bIns="0" rtlCol="0" anchor="t"/>
           <a:lstStyle/>
           <a:p>
-            <a:pPr indent="0" marL="0">
-              <a:buNone/>
-            </a:pPr>
-            <a:r>
-              <a:rPr lang="en-US" sz="1450" b="1" dirty="0">
+            <a:pPr marL="0" indent="0">
+              <a:buNone/>
+            </a:pPr>
+            <a:r>
+              <a:rPr lang="en-US" sz="1450" b="1">
                 <a:solidFill>
                   <a:srgbClr val="E6EDF3"/>
                 </a:solidFill>
@@ -6681,11 +6620,19 @@
                 <a:ea typeface="Calibri" pitchFamily="34" charset="-122"/>
                 <a:cs typeface="Calibri" pitchFamily="34" charset="-120"/>
               </a:rPr>
-              <a:t>Numéro de version en texte  </a:t>
-            </a:r>
-            <a:pPr indent="0" marL="0">
-              <a:buNone/>
-            </a:pPr>
+              <a:t>Numéro de Version en </a:t>
+            </a:r>
+            <a:r>
+              <a:rPr lang="en-US" sz="1450" b="1" dirty="0">
+                <a:solidFill>
+                  <a:srgbClr val="E6EDF3"/>
+                </a:solidFill>
+                <a:latin typeface="Calibri" pitchFamily="34" charset="0"/>
+                <a:ea typeface="Calibri" pitchFamily="34" charset="-122"/>
+                <a:cs typeface="Calibri" pitchFamily="34" charset="-120"/>
+              </a:rPr>
+              <a:t>texte  </a:t>
+            </a:r>
             <a:r>
               <a:rPr lang="en-US" sz="1450" dirty="0">
                 <a:solidFill>
@@ -6727,7 +6674,7 @@
             <a:prstDash val="solid"/>
           </a:ln>
           <a:effectLst>
-            <a:outerShdw sx="100000" sy="100000" kx="0" ky="0" algn="bl" rotWithShape="0" blurRad="101600" dist="38100" dir="5400000">
+            <a:outerShdw blurRad="101600" dist="38100" dir="5400000" algn="bl" rotWithShape="0">
               <a:srgbClr val="000000">
                 <a:alpha val="45000"/>
               </a:srgbClr>
@@ -6756,7 +6703,7 @@
           <a:bodyPr wrap="square" lIns="0" tIns="0" rIns="0" bIns="0" rtlCol="0" anchor="ctr"/>
           <a:lstStyle/>
           <a:p>
-            <a:pPr indent="0" marL="0">
+            <a:pPr marL="0" indent="0">
               <a:buNone/>
             </a:pPr>
             <a:r>
@@ -6795,7 +6742,7 @@
           <a:bodyPr wrap="square" lIns="0" tIns="0" rIns="0" bIns="0" rtlCol="0" anchor="t"/>
           <a:lstStyle/>
           <a:p>
-            <a:pPr indent="0" marL="0">
+            <a:pPr marL="0" indent="0">
               <a:lnSpc>
                 <a:spcPct val="115000"/>
               </a:lnSpc>
@@ -6812,12 +6759,6 @@
               </a:rPr>
               <a:t>La 3e forme normale </a:t>
             </a:r>
-            <a:pPr indent="0" marL="0">
-              <a:lnSpc>
-                <a:spcPct val="115000"/>
-              </a:lnSpc>
-              <a:buNone/>
-            </a:pPr>
             <a:r>
               <a:rPr lang="en-US" sz="1450" dirty="0">
                 <a:solidFill>
@@ -6830,12 +6771,6 @@
               <a:t>évite de stocker deux fois la même information : chaque donnée vit à un seul endroit.
 </a:t>
             </a:r>
-            <a:pPr indent="0" marL="0">
-              <a:lnSpc>
-                <a:spcPct val="115000"/>
-              </a:lnSpc>
-              <a:buNone/>
-            </a:pPr>
             <a:r>
               <a:rPr lang="en-US" sz="1450" b="1" dirty="0">
                 <a:solidFill>
@@ -6847,12 +6782,6 @@
               </a:rPr>
               <a:t>Les contraintes </a:t>
             </a:r>
-            <a:pPr indent="0" marL="0">
-              <a:lnSpc>
-                <a:spcPct val="115000"/>
-              </a:lnSpc>
-              <a:buNone/>
-            </a:pPr>
             <a:r>
               <a:rPr lang="en-US" sz="1450" dirty="0">
                 <a:solidFill>
@@ -6864,12 +6793,6 @@
               </a:rPr>
               <a:t>(clé étrangère, unicité) font que la base </a:t>
             </a:r>
-            <a:pPr indent="0" marL="0">
-              <a:lnSpc>
-                <a:spcPct val="115000"/>
-              </a:lnSpc>
-              <a:buNone/>
-            </a:pPr>
             <a:r>
               <a:rPr lang="en-US" sz="1450" b="1" dirty="0">
                 <a:solidFill>
@@ -6881,12 +6804,6 @@
               </a:rPr>
               <a:t>refuse elle-même les incohérences</a:t>
             </a:r>
-            <a:pPr indent="0" marL="0">
-              <a:lnSpc>
-                <a:spcPct val="115000"/>
-              </a:lnSpc>
-              <a:buNone/>
-            </a:pPr>
             <a:r>
               <a:rPr lang="en-US" sz="1450" dirty="0">
                 <a:solidFill>
@@ -6918,6 +6835,7 @@
         <a:solidFill>
           <a:srgbClr val="0D1117"/>
         </a:solidFill>
+        <a:effectLst/>
       </p:bgPr>
     </p:bg>
     <p:spTree>
@@ -6955,7 +6873,7 @@
           <a:bodyPr wrap="square" lIns="0" tIns="0" rIns="0" bIns="0" rtlCol="0" anchor="ctr"/>
           <a:lstStyle/>
           <a:p>
-            <a:pPr indent="0" marL="0">
+            <a:pPr marL="0" indent="0">
               <a:buNone/>
             </a:pPr>
             <a:r>
@@ -6994,7 +6912,7 @@
           <a:bodyPr wrap="square" lIns="0" tIns="0" rIns="0" bIns="0" rtlCol="0" anchor="ctr"/>
           <a:lstStyle/>
           <a:p>
-            <a:pPr indent="0" marL="0">
+            <a:pPr marL="0" indent="0">
               <a:buNone/>
             </a:pPr>
             <a:r>
@@ -7033,7 +6951,7 @@
           <a:bodyPr wrap="square" lIns="0" tIns="0" rIns="0" bIns="0" rtlCol="0" anchor="ctr"/>
           <a:lstStyle/>
           <a:p>
-            <a:pPr indent="0" marL="0">
+            <a:pPr marL="0" indent="0">
               <a:buNone/>
             </a:pPr>
             <a:r>
@@ -7072,7 +6990,7 @@
           <a:bodyPr wrap="square" lIns="0" tIns="0" rIns="0" bIns="0" rtlCol="0" anchor="ctr"/>
           <a:lstStyle/>
           <a:p>
-            <a:pPr algn="ctr" indent="0" marL="0">
+            <a:pPr marL="0" indent="0" algn="ctr">
               <a:buNone/>
             </a:pPr>
             <a:r>
@@ -7111,7 +7029,7 @@
           <a:bodyPr wrap="square" lIns="0" tIns="0" rIns="0" bIns="0" rtlCol="0" anchor="ctr"/>
           <a:lstStyle/>
           <a:p>
-            <a:pPr algn="ctr" indent="0" marL="0">
+            <a:pPr marL="0" indent="0" algn="ctr">
               <a:buNone/>
             </a:pPr>
             <a:r>
@@ -7150,7 +7068,7 @@
           <a:bodyPr wrap="square" lIns="0" tIns="0" rIns="0" bIns="0" rtlCol="0" anchor="ctr"/>
           <a:lstStyle/>
           <a:p>
-            <a:pPr algn="ctr" indent="0" marL="0">
+            <a:pPr marL="0" indent="0" algn="ctr">
               <a:buNone/>
             </a:pPr>
             <a:r>
@@ -7189,7 +7107,7 @@
           <a:bodyPr wrap="square" lIns="0" tIns="0" rIns="0" bIns="0" rtlCol="0" anchor="ctr"/>
           <a:lstStyle/>
           <a:p>
-            <a:pPr algn="ctr" indent="0" marL="0">
+            <a:pPr marL="0" indent="0" algn="ctr">
               <a:buNone/>
             </a:pPr>
             <a:r>
@@ -7228,7 +7146,7 @@
           <a:bodyPr wrap="square" lIns="0" tIns="0" rIns="0" bIns="0" rtlCol="0" anchor="ctr"/>
           <a:lstStyle/>
           <a:p>
-            <a:pPr algn="ctr" indent="0" marL="0">
+            <a:pPr marL="0" indent="0" algn="ctr">
               <a:buNone/>
             </a:pPr>
             <a:r>
@@ -7267,7 +7185,7 @@
           <a:bodyPr wrap="square" lIns="0" tIns="0" rIns="0" bIns="0" rtlCol="0" anchor="ctr"/>
           <a:lstStyle/>
           <a:p>
-            <a:pPr algn="ctr" indent="0" marL="0">
+            <a:pPr marL="0" indent="0" algn="ctr">
               <a:buNone/>
             </a:pPr>
             <a:r>
@@ -7306,7 +7224,7 @@
           <a:bodyPr wrap="square" lIns="0" tIns="0" rIns="0" bIns="0" rtlCol="0" anchor="ctr"/>
           <a:lstStyle/>
           <a:p>
-            <a:pPr algn="ctr" indent="0" marL="0">
+            <a:pPr marL="0" indent="0" algn="ctr">
               <a:buNone/>
             </a:pPr>
             <a:r>
@@ -7345,7 +7263,7 @@
           <a:bodyPr wrap="square" lIns="0" tIns="0" rIns="0" bIns="0" rtlCol="0" anchor="ctr"/>
           <a:lstStyle/>
           <a:p>
-            <a:pPr algn="ctr" indent="0" marL="0">
+            <a:pPr marL="0" indent="0" algn="ctr">
               <a:buNone/>
             </a:pPr>
             <a:r>
@@ -7389,7 +7307,7 @@
             <a:prstDash val="solid"/>
           </a:ln>
           <a:effectLst>
-            <a:outerShdw sx="100000" sy="100000" kx="0" ky="0" algn="bl" rotWithShape="0" blurRad="101600" dist="38100" dir="5400000">
+            <a:outerShdw blurRad="101600" dist="38100" dir="5400000" algn="bl" rotWithShape="0">
               <a:srgbClr val="000000">
                 <a:alpha val="45000"/>
               </a:srgbClr>
@@ -7418,7 +7336,7 @@
           <a:bodyPr wrap="square" lIns="0" tIns="0" rIns="0" bIns="0" rtlCol="0" anchor="ctr"/>
           <a:lstStyle/>
           <a:p>
-            <a:pPr indent="0" marL="0">
+            <a:pPr marL="0" indent="0">
               <a:buNone/>
             </a:pPr>
             <a:r>
@@ -7457,7 +7375,7 @@
           <a:bodyPr wrap="square" lIns="0" tIns="0" rIns="0" bIns="0" rtlCol="0" anchor="ctr"/>
           <a:lstStyle/>
           <a:p>
-            <a:pPr indent="0" marL="0">
+            <a:pPr marL="0" indent="0">
               <a:buNone/>
             </a:pPr>
             <a:r>
@@ -7501,7 +7419,7 @@
             <a:prstDash val="solid"/>
           </a:ln>
           <a:effectLst>
-            <a:outerShdw sx="100000" sy="100000" kx="0" ky="0" algn="bl" rotWithShape="0" blurRad="101600" dist="38100" dir="5400000">
+            <a:outerShdw blurRad="101600" dist="38100" dir="5400000" algn="bl" rotWithShape="0">
               <a:srgbClr val="000000">
                 <a:alpha val="45000"/>
               </a:srgbClr>
@@ -7530,7 +7448,7 @@
           <a:bodyPr wrap="square" lIns="0" tIns="0" rIns="0" bIns="0" rtlCol="0" anchor="ctr"/>
           <a:lstStyle/>
           <a:p>
-            <a:pPr indent="0" marL="0">
+            <a:pPr marL="0" indent="0">
               <a:buNone/>
             </a:pPr>
             <a:r>
@@ -7569,7 +7487,7 @@
           <a:bodyPr wrap="square" lIns="0" tIns="0" rIns="0" bIns="0" rtlCol="0" anchor="ctr"/>
           <a:lstStyle/>
           <a:p>
-            <a:pPr indent="0" marL="0">
+            <a:pPr marL="0" indent="0">
               <a:buNone/>
             </a:pPr>
             <a:r>
@@ -7603,6 +7521,7 @@
         <a:solidFill>
           <a:srgbClr val="0D1117"/>
         </a:solidFill>
+        <a:effectLst/>
       </p:bgPr>
     </p:bg>
     <p:spTree>
@@ -7640,7 +7559,7 @@
           <a:bodyPr wrap="square" lIns="0" tIns="0" rIns="0" bIns="0" rtlCol="0" anchor="ctr"/>
           <a:lstStyle/>
           <a:p>
-            <a:pPr indent="0" marL="0">
+            <a:pPr marL="0" indent="0">
               <a:buNone/>
             </a:pPr>
             <a:r>
@@ -7679,7 +7598,7 @@
           <a:bodyPr wrap="square" lIns="0" tIns="0" rIns="0" bIns="0" rtlCol="0" anchor="ctr"/>
           <a:lstStyle/>
           <a:p>
-            <a:pPr indent="0" marL="0">
+            <a:pPr marL="0" indent="0">
               <a:buNone/>
             </a:pPr>
             <a:r>
@@ -7723,7 +7642,7 @@
             <a:prstDash val="solid"/>
           </a:ln>
           <a:effectLst>
-            <a:outerShdw sx="100000" sy="100000" kx="0" ky="0" algn="bl" rotWithShape="0" blurRad="101600" dist="38100" dir="5400000">
+            <a:outerShdw blurRad="101600" dist="38100" dir="5400000" algn="bl" rotWithShape="0">
               <a:srgbClr val="000000">
                 <a:alpha val="45000"/>
               </a:srgbClr>
@@ -7752,7 +7671,7 @@
           <a:bodyPr wrap="square" lIns="0" tIns="0" rIns="0" bIns="0" rtlCol="0" anchor="ctr"/>
           <a:lstStyle/>
           <a:p>
-            <a:pPr indent="0" marL="0">
+            <a:pPr marL="0" indent="0">
               <a:buNone/>
             </a:pPr>
             <a:r>
@@ -7791,7 +7710,7 @@
           <a:bodyPr wrap="square" lIns="0" tIns="0" rIns="0" bIns="0" rtlCol="0" anchor="t"/>
           <a:lstStyle/>
           <a:p>
-            <a:pPr indent="0" marL="0">
+            <a:pPr marL="0" indent="0">
               <a:lnSpc>
                 <a:spcPct val="115000"/>
               </a:lnSpc>
@@ -7808,12 +7727,6 @@
               </a:rPr>
               <a:t>Problème : </a:t>
             </a:r>
-            <a:pPr indent="0" marL="0">
-              <a:lnSpc>
-                <a:spcPct val="115000"/>
-              </a:lnSpc>
-              <a:buNone/>
-            </a:pPr>
             <a:r>
               <a:rPr lang="en-US" sz="1400" dirty="0">
                 <a:solidFill>
@@ -7826,12 +7739,6 @@
               <a:t>sur un PC en langue française, tous les cours de bourse s'affichent à 0,00.
 </a:t>
             </a:r>
-            <a:pPr indent="0" marL="0">
-              <a:lnSpc>
-                <a:spcPct val="115000"/>
-              </a:lnSpc>
-              <a:buNone/>
-            </a:pPr>
             <a:r>
               <a:rPr lang="en-US" sz="1400" b="1" dirty="0">
                 <a:solidFill>
@@ -7843,12 +7750,6 @@
               </a:rPr>
               <a:t>Solution : </a:t>
             </a:r>
-            <a:pPr indent="0" marL="0">
-              <a:lnSpc>
-                <a:spcPct val="115000"/>
-              </a:lnSpc>
-              <a:buNone/>
-            </a:pPr>
             <a:r>
               <a:rPr lang="en-US" sz="1400" dirty="0">
                 <a:solidFill>
@@ -7890,7 +7791,7 @@
             <a:prstDash val="solid"/>
           </a:ln>
           <a:effectLst>
-            <a:outerShdw sx="100000" sy="100000" kx="0" ky="0" algn="bl" rotWithShape="0" blurRad="101600" dist="38100" dir="5400000">
+            <a:outerShdw blurRad="101600" dist="38100" dir="5400000" algn="bl" rotWithShape="0">
               <a:srgbClr val="000000">
                 <a:alpha val="45000"/>
               </a:srgbClr>
@@ -7919,7 +7820,7 @@
           <a:bodyPr wrap="square" lIns="0" tIns="0" rIns="0" bIns="0" rtlCol="0" anchor="ctr"/>
           <a:lstStyle/>
           <a:p>
-            <a:pPr indent="0" marL="0">
+            <a:pPr marL="0" indent="0">
               <a:buNone/>
             </a:pPr>
             <a:r>
@@ -7958,7 +7859,7 @@
           <a:bodyPr wrap="square" lIns="0" tIns="0" rIns="0" bIns="0" rtlCol="0" anchor="t"/>
           <a:lstStyle/>
           <a:p>
-            <a:pPr indent="0" marL="0">
+            <a:pPr marL="0" indent="0">
               <a:lnSpc>
                 <a:spcPct val="115000"/>
               </a:lnSpc>
@@ -7975,12 +7876,6 @@
               </a:rPr>
               <a:t>Problème : </a:t>
             </a:r>
-            <a:pPr indent="0" marL="0">
-              <a:lnSpc>
-                <a:spcPct val="115000"/>
-              </a:lnSpc>
-              <a:buNone/>
-            </a:pPr>
             <a:r>
               <a:rPr lang="en-US" sz="1400" dirty="0">
                 <a:solidFill>
@@ -7993,12 +7888,6 @@
               <a:t>après une vente, le solde du portefeuille ne se met pas à jour à l'écran.
 </a:t>
             </a:r>
-            <a:pPr indent="0" marL="0">
-              <a:lnSpc>
-                <a:spcPct val="115000"/>
-              </a:lnSpc>
-              <a:buNone/>
-            </a:pPr>
             <a:r>
               <a:rPr lang="en-US" sz="1400" b="1" dirty="0">
                 <a:solidFill>
@@ -8010,12 +7899,6 @@
               </a:rPr>
               <a:t>Solution : </a:t>
             </a:r>
-            <a:pPr indent="0" marL="0">
-              <a:lnSpc>
-                <a:spcPct val="115000"/>
-              </a:lnSpc>
-              <a:buNone/>
-            </a:pPr>
             <a:r>
               <a:rPr lang="en-US" sz="1400" dirty="0">
                 <a:solidFill>
@@ -8047,6 +7930,7 @@
         <a:solidFill>
           <a:srgbClr val="0D1117"/>
         </a:solidFill>
+        <a:effectLst/>
       </p:bgPr>
     </p:bg>
     <p:spTree>
@@ -8084,7 +7968,7 @@
           <a:bodyPr wrap="square" lIns="0" tIns="0" rIns="0" bIns="0" rtlCol="0" anchor="ctr"/>
           <a:lstStyle/>
           <a:p>
-            <a:pPr indent="0" marL="0">
+            <a:pPr marL="0" indent="0">
               <a:buNone/>
             </a:pPr>
             <a:r>
@@ -8123,7 +8007,7 @@
           <a:bodyPr wrap="square" lIns="0" tIns="0" rIns="0" bIns="0" rtlCol="0" anchor="ctr"/>
           <a:lstStyle/>
           <a:p>
-            <a:pPr indent="0" marL="0">
+            <a:pPr marL="0" indent="0">
               <a:buNone/>
             </a:pPr>
             <a:r>
@@ -8182,7 +8066,7 @@
           <a:bodyPr wrap="square" lIns="0" tIns="0" rIns="0" bIns="0" rtlCol="0" anchor="t"/>
           <a:lstStyle/>
           <a:p>
-            <a:pPr indent="0" marL="0">
+            <a:pPr marL="0" indent="0">
               <a:buNone/>
             </a:pPr>
             <a:r>
@@ -8196,9 +8080,6 @@
               </a:rPr>
               <a:t>Pourquoi Code-First  </a:t>
             </a:r>
-            <a:pPr indent="0" marL="0">
-              <a:buNone/>
-            </a:pPr>
             <a:r>
               <a:rPr lang="en-US" sz="1450" dirty="0">
                 <a:solidFill>
@@ -8255,7 +8136,7 @@
           <a:bodyPr wrap="square" lIns="0" tIns="0" rIns="0" bIns="0" rtlCol="0" anchor="t"/>
           <a:lstStyle/>
           <a:p>
-            <a:pPr indent="0" marL="0">
+            <a:pPr marL="0" indent="0">
               <a:buNone/>
             </a:pPr>
             <a:r>
@@ -8269,9 +8150,6 @@
               </a:rPr>
               <a:t>Le principe  </a:t>
             </a:r>
-            <a:pPr indent="0" marL="0">
-              <a:buNone/>
-            </a:pPr>
             <a:r>
               <a:rPr lang="en-US" sz="1450" dirty="0">
                 <a:solidFill>
@@ -8328,7 +8206,7 @@
           <a:bodyPr wrap="square" lIns="0" tIns="0" rIns="0" bIns="0" rtlCol="0" anchor="t"/>
           <a:lstStyle/>
           <a:p>
-            <a:pPr indent="0" marL="0">
+            <a:pPr marL="0" indent="0">
               <a:buNone/>
             </a:pPr>
             <a:r>
@@ -8342,9 +8220,6 @@
               </a:rPr>
               <a:t>.NET 10 et EF Core 10  </a:t>
             </a:r>
-            <a:pPr indent="0" marL="0">
-              <a:buNone/>
-            </a:pPr>
             <a:r>
               <a:rPr lang="en-US" sz="1450" dirty="0">
                 <a:solidFill>
@@ -8401,7 +8276,7 @@
           <a:bodyPr wrap="square" lIns="0" tIns="0" rIns="0" bIns="0" rtlCol="0" anchor="t"/>
           <a:lstStyle/>
           <a:p>
-            <a:pPr indent="0" marL="0">
+            <a:pPr marL="0" indent="0">
               <a:buNone/>
             </a:pPr>
             <a:r>
@@ -8415,9 +8290,6 @@
               </a:rPr>
               <a:t>En complément  </a:t>
             </a:r>
-            <a:pPr indent="0" marL="0">
-              <a:buNone/>
-            </a:pPr>
             <a:r>
               <a:rPr lang="en-US" sz="1450" dirty="0">
                 <a:solidFill>
@@ -8459,7 +8331,7 @@
             <a:prstDash val="solid"/>
           </a:ln>
           <a:effectLst>
-            <a:outerShdw sx="100000" sy="100000" kx="0" ky="0" algn="bl" rotWithShape="0" blurRad="101600" dist="38100" dir="5400000">
+            <a:outerShdw blurRad="101600" dist="38100" dir="5400000" algn="bl" rotWithShape="0">
               <a:srgbClr val="000000">
                 <a:alpha val="45000"/>
               </a:srgbClr>
@@ -8488,7 +8360,7 @@
           <a:bodyPr wrap="square" lIns="0" tIns="0" rIns="0" bIns="0" rtlCol="0" anchor="t"/>
           <a:lstStyle/>
           <a:p>
-            <a:pPr indent="0" marL="0">
+            <a:pPr marL="0" indent="0">
               <a:lnSpc>
                 <a:spcPct val="118000"/>
               </a:lnSpc>
@@ -8505,7 +8377,21 @@
               </a:rPr>
               <a:t>public class </a:t>
             </a:r>
-            <a:pPr indent="0" marL="0">
+            <a:r>
+              <a:rPr lang="en-US" sz="1250" dirty="0">
+                <a:solidFill>
+                  <a:srgbClr val="79C0FF"/>
+                </a:solidFill>
+                <a:latin typeface="Consolas" pitchFamily="34" charset="0"/>
+                <a:ea typeface="Consolas" pitchFamily="34" charset="-122"/>
+                <a:cs typeface="Consolas" pitchFamily="34" charset="-120"/>
+              </a:rPr>
+              <a:t>Ticket</a:t>
+            </a:r>
+            <a:endParaRPr lang="en-US" sz="1250" dirty="0"/>
+          </a:p>
+          <a:p>
+            <a:pPr marL="0" indent="0">
               <a:lnSpc>
                 <a:spcPct val="118000"/>
               </a:lnSpc>
@@ -8514,18 +8400,18 @@
             <a:r>
               <a:rPr lang="en-US" sz="1250" dirty="0">
                 <a:solidFill>
-                  <a:srgbClr val="79C0FF"/>
-                </a:solidFill>
-                <a:latin typeface="Consolas" pitchFamily="34" charset="0"/>
-                <a:ea typeface="Consolas" pitchFamily="34" charset="-122"/>
-                <a:cs typeface="Consolas" pitchFamily="34" charset="-120"/>
-              </a:rPr>
-              <a:t>Ticket</a:t>
+                  <a:srgbClr val="E6EDF3"/>
+                </a:solidFill>
+                <a:latin typeface="Consolas" pitchFamily="34" charset="0"/>
+                <a:ea typeface="Consolas" pitchFamily="34" charset="-122"/>
+                <a:cs typeface="Consolas" pitchFamily="34" charset="-120"/>
+              </a:rPr>
+              <a:t>{</a:t>
             </a:r>
             <a:endParaRPr lang="en-US" sz="1250" dirty="0"/>
           </a:p>
           <a:p>
-            <a:pPr indent="0" marL="0">
+            <a:pPr marL="0" indent="0">
               <a:lnSpc>
                 <a:spcPct val="118000"/>
               </a:lnSpc>
@@ -8534,18 +8420,29 @@
             <a:r>
               <a:rPr lang="en-US" sz="1250" dirty="0">
                 <a:solidFill>
+                  <a:srgbClr val="FF7B72"/>
+                </a:solidFill>
+                <a:latin typeface="Consolas" pitchFamily="34" charset="0"/>
+                <a:ea typeface="Consolas" pitchFamily="34" charset="-122"/>
+                <a:cs typeface="Consolas" pitchFamily="34" charset="-120"/>
+              </a:rPr>
+              <a:t>    public int </a:t>
+            </a:r>
+            <a:r>
+              <a:rPr lang="en-US" sz="1250" dirty="0">
+                <a:solidFill>
                   <a:srgbClr val="E6EDF3"/>
                 </a:solidFill>
                 <a:latin typeface="Consolas" pitchFamily="34" charset="0"/>
                 <a:ea typeface="Consolas" pitchFamily="34" charset="-122"/>
                 <a:cs typeface="Consolas" pitchFamily="34" charset="-120"/>
               </a:rPr>
-              <a:t>{</a:t>
+              <a:t>Id { get; set; }</a:t>
             </a:r>
             <a:endParaRPr lang="en-US" sz="1250" dirty="0"/>
           </a:p>
           <a:p>
-            <a:pPr indent="0" marL="0">
+            <a:pPr marL="0" indent="0">
               <a:lnSpc>
                 <a:spcPct val="118000"/>
               </a:lnSpc>
@@ -8560,9 +8457,23 @@
                 <a:ea typeface="Consolas" pitchFamily="34" charset="-122"/>
                 <a:cs typeface="Consolas" pitchFamily="34" charset="-120"/>
               </a:rPr>
-              <a:t>    public int </a:t>
-            </a:r>
-            <a:pPr indent="0" marL="0">
+              <a:t>    public DateOnly </a:t>
+            </a:r>
+            <a:r>
+              <a:rPr lang="en-US" sz="1250" dirty="0">
+                <a:solidFill>
+                  <a:srgbClr val="E6EDF3"/>
+                </a:solidFill>
+                <a:latin typeface="Consolas" pitchFamily="34" charset="0"/>
+                <a:ea typeface="Consolas" pitchFamily="34" charset="-122"/>
+                <a:cs typeface="Consolas" pitchFamily="34" charset="-120"/>
+              </a:rPr>
+              <a:t>DateCreation</a:t>
+            </a:r>
+            <a:endParaRPr lang="en-US" sz="1250" dirty="0"/>
+          </a:p>
+          <a:p>
+            <a:pPr marL="0" indent="0">
               <a:lnSpc>
                 <a:spcPct val="118000"/>
               </a:lnSpc>
@@ -8571,18 +8482,29 @@
             <a:r>
               <a:rPr lang="en-US" sz="1250" dirty="0">
                 <a:solidFill>
+                  <a:srgbClr val="FF7B72"/>
+                </a:solidFill>
+                <a:latin typeface="Consolas" pitchFamily="34" charset="0"/>
+                <a:ea typeface="Consolas" pitchFamily="34" charset="-122"/>
+                <a:cs typeface="Consolas" pitchFamily="34" charset="-120"/>
+              </a:rPr>
+              <a:t>    public string </a:t>
+            </a:r>
+            <a:r>
+              <a:rPr lang="en-US" sz="1250" dirty="0">
+                <a:solidFill>
                   <a:srgbClr val="E6EDF3"/>
                 </a:solidFill>
                 <a:latin typeface="Consolas" pitchFamily="34" charset="0"/>
                 <a:ea typeface="Consolas" pitchFamily="34" charset="-122"/>
                 <a:cs typeface="Consolas" pitchFamily="34" charset="-120"/>
               </a:rPr>
-              <a:t>Id { get; set; }</a:t>
+              <a:t>Probleme</a:t>
             </a:r>
             <a:endParaRPr lang="en-US" sz="1250" dirty="0"/>
           </a:p>
           <a:p>
-            <a:pPr indent="0" marL="0">
+            <a:pPr marL="0" indent="0">
               <a:lnSpc>
                 <a:spcPct val="118000"/>
               </a:lnSpc>
@@ -8597,9 +8519,23 @@
                 <a:ea typeface="Consolas" pitchFamily="34" charset="-122"/>
                 <a:cs typeface="Consolas" pitchFamily="34" charset="-120"/>
               </a:rPr>
-              <a:t>    public DateOnly </a:t>
-            </a:r>
-            <a:pPr indent="0" marL="0">
+              <a:t>    public int </a:t>
+            </a:r>
+            <a:r>
+              <a:rPr lang="en-US" sz="1250" dirty="0">
+                <a:solidFill>
+                  <a:srgbClr val="E6EDF3"/>
+                </a:solidFill>
+                <a:latin typeface="Consolas" pitchFamily="34" charset="0"/>
+                <a:ea typeface="Consolas" pitchFamily="34" charset="-122"/>
+                <a:cs typeface="Consolas" pitchFamily="34" charset="-120"/>
+              </a:rPr>
+              <a:t>CompatibiliteId</a:t>
+            </a:r>
+            <a:endParaRPr lang="en-US" sz="1250" dirty="0"/>
+          </a:p>
+          <a:p>
+            <a:pPr marL="0" indent="0">
               <a:lnSpc>
                 <a:spcPct val="118000"/>
               </a:lnSpc>
@@ -8614,12 +8550,12 @@
                 <a:ea typeface="Consolas" pitchFamily="34" charset="-122"/>
                 <a:cs typeface="Consolas" pitchFamily="34" charset="-120"/>
               </a:rPr>
-              <a:t>DateCreation</a:t>
+              <a:t>}</a:t>
             </a:r>
             <a:endParaRPr lang="en-US" sz="1250" dirty="0"/>
           </a:p>
           <a:p>
-            <a:pPr indent="0" marL="0">
+            <a:pPr marL="0" indent="0">
               <a:lnSpc>
                 <a:spcPct val="118000"/>
               </a:lnSpc>
@@ -8628,15 +8564,18 @@
             <a:r>
               <a:rPr lang="en-US" sz="1250" dirty="0">
                 <a:solidFill>
-                  <a:srgbClr val="FF7B72"/>
-                </a:solidFill>
-                <a:latin typeface="Consolas" pitchFamily="34" charset="0"/>
-                <a:ea typeface="Consolas" pitchFamily="34" charset="-122"/>
-                <a:cs typeface="Consolas" pitchFamily="34" charset="-120"/>
-              </a:rPr>
-              <a:t>    public string </a:t>
-            </a:r>
-            <a:pPr indent="0" marL="0">
+                  <a:srgbClr val="E6EDF3"/>
+                </a:solidFill>
+                <a:latin typeface="Consolas" pitchFamily="34" charset="0"/>
+                <a:ea typeface="Consolas" pitchFamily="34" charset="-122"/>
+                <a:cs typeface="Consolas" pitchFamily="34" charset="-120"/>
+              </a:rPr>
+              <a:t> </a:t>
+            </a:r>
+            <a:endParaRPr lang="en-US" sz="1250" dirty="0"/>
+          </a:p>
+          <a:p>
+            <a:pPr marL="0" indent="0">
               <a:lnSpc>
                 <a:spcPct val="118000"/>
               </a:lnSpc>
@@ -8645,115 +8584,18 @@
             <a:r>
               <a:rPr lang="en-US" sz="1250" dirty="0">
                 <a:solidFill>
-                  <a:srgbClr val="E6EDF3"/>
-                </a:solidFill>
-                <a:latin typeface="Consolas" pitchFamily="34" charset="0"/>
-                <a:ea typeface="Consolas" pitchFamily="34" charset="-122"/>
-                <a:cs typeface="Consolas" pitchFamily="34" charset="-120"/>
-              </a:rPr>
-              <a:t>Probleme</a:t>
+                  <a:srgbClr val="7EE787"/>
+                </a:solidFill>
+                <a:latin typeface="Consolas" pitchFamily="34" charset="0"/>
+                <a:ea typeface="Consolas" pitchFamily="34" charset="-122"/>
+                <a:cs typeface="Consolas" pitchFamily="34" charset="-120"/>
+              </a:rPr>
+              <a:t>&gt; dotnet ef migrations add Init</a:t>
             </a:r>
             <a:endParaRPr lang="en-US" sz="1250" dirty="0"/>
           </a:p>
           <a:p>
-            <a:pPr indent="0" marL="0">
-              <a:lnSpc>
-                <a:spcPct val="118000"/>
-              </a:lnSpc>
-              <a:buNone/>
-            </a:pPr>
-            <a:r>
-              <a:rPr lang="en-US" sz="1250" dirty="0">
-                <a:solidFill>
-                  <a:srgbClr val="FF7B72"/>
-                </a:solidFill>
-                <a:latin typeface="Consolas" pitchFamily="34" charset="0"/>
-                <a:ea typeface="Consolas" pitchFamily="34" charset="-122"/>
-                <a:cs typeface="Consolas" pitchFamily="34" charset="-120"/>
-              </a:rPr>
-              <a:t>    public int </a:t>
-            </a:r>
-            <a:pPr indent="0" marL="0">
-              <a:lnSpc>
-                <a:spcPct val="118000"/>
-              </a:lnSpc>
-              <a:buNone/>
-            </a:pPr>
-            <a:r>
-              <a:rPr lang="en-US" sz="1250" dirty="0">
-                <a:solidFill>
-                  <a:srgbClr val="E6EDF3"/>
-                </a:solidFill>
-                <a:latin typeface="Consolas" pitchFamily="34" charset="0"/>
-                <a:ea typeface="Consolas" pitchFamily="34" charset="-122"/>
-                <a:cs typeface="Consolas" pitchFamily="34" charset="-120"/>
-              </a:rPr>
-              <a:t>CompatibiliteId</a:t>
-            </a:r>
-            <a:endParaRPr lang="en-US" sz="1250" dirty="0"/>
-          </a:p>
-          <a:p>
-            <a:pPr indent="0" marL="0">
-              <a:lnSpc>
-                <a:spcPct val="118000"/>
-              </a:lnSpc>
-              <a:buNone/>
-            </a:pPr>
-            <a:r>
-              <a:rPr lang="en-US" sz="1250" dirty="0">
-                <a:solidFill>
-                  <a:srgbClr val="E6EDF3"/>
-                </a:solidFill>
-                <a:latin typeface="Consolas" pitchFamily="34" charset="0"/>
-                <a:ea typeface="Consolas" pitchFamily="34" charset="-122"/>
-                <a:cs typeface="Consolas" pitchFamily="34" charset="-120"/>
-              </a:rPr>
-              <a:t>}</a:t>
-            </a:r>
-            <a:endParaRPr lang="en-US" sz="1250" dirty="0"/>
-          </a:p>
-          <a:p>
-            <a:pPr indent="0" marL="0">
-              <a:lnSpc>
-                <a:spcPct val="118000"/>
-              </a:lnSpc>
-              <a:buNone/>
-            </a:pPr>
-            <a:r>
-              <a:rPr lang="en-US" sz="1250" dirty="0">
-                <a:solidFill>
-                  <a:srgbClr val="E6EDF3"/>
-                </a:solidFill>
-                <a:latin typeface="Consolas" pitchFamily="34" charset="0"/>
-                <a:ea typeface="Consolas" pitchFamily="34" charset="-122"/>
-                <a:cs typeface="Consolas" pitchFamily="34" charset="-120"/>
-              </a:rPr>
-              <a:t> </a:t>
-            </a:r>
-            <a:endParaRPr lang="en-US" sz="1250" dirty="0"/>
-          </a:p>
-          <a:p>
-            <a:pPr indent="0" marL="0">
-              <a:lnSpc>
-                <a:spcPct val="118000"/>
-              </a:lnSpc>
-              <a:buNone/>
-            </a:pPr>
-            <a:r>
-              <a:rPr lang="en-US" sz="1250" dirty="0">
-                <a:solidFill>
-                  <a:srgbClr val="7EE787"/>
-                </a:solidFill>
-                <a:latin typeface="Consolas" pitchFamily="34" charset="0"/>
-                <a:ea typeface="Consolas" pitchFamily="34" charset="-122"/>
-                <a:cs typeface="Consolas" pitchFamily="34" charset="-120"/>
-              </a:rPr>
-              <a:t>&gt; dotnet ef migrations add Init</a:t>
-            </a:r>
-            <a:endParaRPr lang="en-US" sz="1250" dirty="0"/>
-          </a:p>
-          <a:p>
-            <a:pPr indent="0" marL="0">
+            <a:pPr marL="0" indent="0">
               <a:lnSpc>
                 <a:spcPct val="118000"/>
               </a:lnSpc>
@@ -8790,6 +8632,7 @@
         <a:solidFill>
           <a:srgbClr val="0D1117"/>
         </a:solidFill>
+        <a:effectLst/>
       </p:bgPr>
     </p:bg>
     <p:spTree>
@@ -8827,7 +8670,7 @@
           <a:bodyPr wrap="square" lIns="0" tIns="0" rIns="0" bIns="0" rtlCol="0" anchor="ctr"/>
           <a:lstStyle/>
           <a:p>
-            <a:pPr indent="0" marL="0">
+            <a:pPr marL="0" indent="0">
               <a:buNone/>
             </a:pPr>
             <a:r>
@@ -8866,7 +8709,7 @@
           <a:bodyPr wrap="square" lIns="0" tIns="0" rIns="0" bIns="0" rtlCol="0" anchor="ctr"/>
           <a:lstStyle/>
           <a:p>
-            <a:pPr indent="0" marL="0">
+            <a:pPr marL="0" indent="0">
               <a:buNone/>
             </a:pPr>
             <a:r>
@@ -8905,7 +8748,7 @@
           <a:bodyPr wrap="square" lIns="0" tIns="0" rIns="0" bIns="0" rtlCol="0" anchor="ctr"/>
           <a:lstStyle/>
           <a:p>
-            <a:pPr indent="0" marL="0">
+            <a:pPr marL="0" indent="0">
               <a:buNone/>
             </a:pPr>
             <a:r>
@@ -8949,7 +8792,7 @@
             <a:prstDash val="solid"/>
           </a:ln>
           <a:effectLst>
-            <a:outerShdw sx="100000" sy="100000" kx="0" ky="0" algn="bl" rotWithShape="0" blurRad="101600" dist="38100" dir="5400000">
+            <a:outerShdw blurRad="101600" dist="38100" dir="5400000" algn="bl" rotWithShape="0">
               <a:srgbClr val="000000">
                 <a:alpha val="45000"/>
               </a:srgbClr>
@@ -8978,7 +8821,7 @@
           <a:bodyPr wrap="square" lIns="0" tIns="0" rIns="0" bIns="0" rtlCol="0" anchor="ctr"/>
           <a:lstStyle/>
           <a:p>
-            <a:pPr algn="ctr" indent="0" marL="0">
+            <a:pPr marL="0" indent="0" algn="ctr">
               <a:buNone/>
             </a:pPr>
             <a:r>
@@ -9017,7 +8860,7 @@
           <a:bodyPr wrap="square" lIns="0" tIns="0" rIns="0" bIns="0" rtlCol="0" anchor="ctr"/>
           <a:lstStyle/>
           <a:p>
-            <a:pPr algn="ctr" indent="0" marL="0">
+            <a:pPr marL="0" indent="0" algn="ctr">
               <a:buNone/>
             </a:pPr>
             <a:r>
@@ -9061,7 +8904,7 @@
             <a:prstDash val="solid"/>
           </a:ln>
           <a:effectLst>
-            <a:outerShdw sx="100000" sy="100000" kx="0" ky="0" algn="bl" rotWithShape="0" blurRad="101600" dist="38100" dir="5400000">
+            <a:outerShdw blurRad="101600" dist="38100" dir="5400000" algn="bl" rotWithShape="0">
               <a:srgbClr val="000000">
                 <a:alpha val="45000"/>
               </a:srgbClr>
@@ -9090,7 +8933,7 @@
           <a:bodyPr wrap="square" lIns="0" tIns="0" rIns="0" bIns="0" rtlCol="0" anchor="ctr"/>
           <a:lstStyle/>
           <a:p>
-            <a:pPr algn="ctr" indent="0" marL="0">
+            <a:pPr marL="0" indent="0" algn="ctr">
               <a:buNone/>
             </a:pPr>
             <a:r>
@@ -9129,7 +8972,7 @@
           <a:bodyPr wrap="square" lIns="0" tIns="0" rIns="0" bIns="0" rtlCol="0" anchor="ctr"/>
           <a:lstStyle/>
           <a:p>
-            <a:pPr algn="ctr" indent="0" marL="0">
+            <a:pPr marL="0" indent="0" algn="ctr">
               <a:buNone/>
             </a:pPr>
             <a:r>
@@ -9173,7 +9016,7 @@
             <a:prstDash val="solid"/>
           </a:ln>
           <a:effectLst>
-            <a:outerShdw sx="100000" sy="100000" kx="0" ky="0" algn="bl" rotWithShape="0" blurRad="101600" dist="38100" dir="5400000">
+            <a:outerShdw blurRad="101600" dist="38100" dir="5400000" algn="bl" rotWithShape="0">
               <a:srgbClr val="000000">
                 <a:alpha val="45000"/>
               </a:srgbClr>
@@ -9202,7 +9045,7 @@
           <a:bodyPr wrap="square" lIns="0" tIns="0" rIns="0" bIns="0" rtlCol="0" anchor="ctr"/>
           <a:lstStyle/>
           <a:p>
-            <a:pPr algn="ctr" indent="0" marL="0">
+            <a:pPr marL="0" indent="0" algn="ctr">
               <a:buNone/>
             </a:pPr>
             <a:r>
@@ -9241,7 +9084,7 @@
           <a:bodyPr wrap="square" lIns="0" tIns="0" rIns="0" bIns="0" rtlCol="0" anchor="ctr"/>
           <a:lstStyle/>
           <a:p>
-            <a:pPr algn="ctr" indent="0" marL="0">
+            <a:pPr marL="0" indent="0" algn="ctr">
               <a:buNone/>
             </a:pPr>
             <a:r>
@@ -9285,7 +9128,7 @@
             <a:prstDash val="solid"/>
           </a:ln>
           <a:effectLst>
-            <a:outerShdw sx="100000" sy="100000" kx="0" ky="0" algn="bl" rotWithShape="0" blurRad="101600" dist="38100" dir="5400000">
+            <a:outerShdw blurRad="101600" dist="38100" dir="5400000" algn="bl" rotWithShape="0">
               <a:srgbClr val="000000">
                 <a:alpha val="45000"/>
               </a:srgbClr>
@@ -9314,7 +9157,7 @@
           <a:bodyPr wrap="square" lIns="0" tIns="0" rIns="0" bIns="0" rtlCol="0" anchor="ctr"/>
           <a:lstStyle/>
           <a:p>
-            <a:pPr algn="ctr" indent="0" marL="0">
+            <a:pPr marL="0" indent="0" algn="ctr">
               <a:buNone/>
             </a:pPr>
             <a:r>
@@ -9353,7 +9196,7 @@
           <a:bodyPr wrap="square" lIns="0" tIns="0" rIns="0" bIns="0" rtlCol="0" anchor="ctr"/>
           <a:lstStyle/>
           <a:p>
-            <a:pPr algn="ctr" indent="0" marL="0">
+            <a:pPr marL="0" indent="0" algn="ctr">
               <a:buNone/>
             </a:pPr>
             <a:r>
@@ -9397,7 +9240,7 @@
             <a:prstDash val="solid"/>
           </a:ln>
           <a:effectLst>
-            <a:outerShdw sx="100000" sy="100000" kx="0" ky="0" algn="bl" rotWithShape="0" blurRad="101600" dist="38100" dir="5400000">
+            <a:outerShdw blurRad="101600" dist="38100" dir="5400000" algn="bl" rotWithShape="0">
               <a:srgbClr val="000000">
                 <a:alpha val="45000"/>
               </a:srgbClr>
@@ -9426,7 +9269,7 @@
           <a:bodyPr wrap="square" lIns="0" tIns="0" rIns="0" bIns="0" rtlCol="0" anchor="ctr"/>
           <a:lstStyle/>
           <a:p>
-            <a:pPr algn="ctr" indent="0" marL="0">
+            <a:pPr marL="0" indent="0" algn="ctr">
               <a:buNone/>
             </a:pPr>
             <a:r>
@@ -9465,7 +9308,7 @@
           <a:bodyPr wrap="square" lIns="0" tIns="0" rIns="0" bIns="0" rtlCol="0" anchor="ctr"/>
           <a:lstStyle/>
           <a:p>
-            <a:pPr algn="ctr" indent="0" marL="0">
+            <a:pPr marL="0" indent="0" algn="ctr">
               <a:buNone/>
             </a:pPr>
             <a:r>
@@ -9509,7 +9352,7 @@
             <a:prstDash val="solid"/>
           </a:ln>
           <a:effectLst>
-            <a:outerShdw sx="100000" sy="100000" kx="0" ky="0" algn="bl" rotWithShape="0" blurRad="101600" dist="38100" dir="5400000">
+            <a:outerShdw blurRad="101600" dist="38100" dir="5400000" algn="bl" rotWithShape="0">
               <a:srgbClr val="000000">
                 <a:alpha val="45000"/>
               </a:srgbClr>
@@ -9538,7 +9381,7 @@
           <a:bodyPr wrap="square" lIns="0" tIns="0" rIns="0" bIns="0" rtlCol="0" anchor="ctr"/>
           <a:lstStyle/>
           <a:p>
-            <a:pPr algn="ctr" indent="0" marL="0">
+            <a:pPr marL="0" indent="0" algn="ctr">
               <a:buNone/>
             </a:pPr>
             <a:r>
@@ -9577,7 +9420,7 @@
           <a:bodyPr wrap="square" lIns="0" tIns="0" rIns="0" bIns="0" rtlCol="0" anchor="ctr"/>
           <a:lstStyle/>
           <a:p>
-            <a:pPr algn="ctr" indent="0" marL="0">
+            <a:pPr marL="0" indent="0" algn="ctr">
               <a:buNone/>
             </a:pPr>
             <a:r>
@@ -9896,4 +9739,299 @@
     </a:ext>
   </a:extLst>
 </a:theme>
+</file>
+
+<file path=ppt/theme/theme2.xml><?xml version="1.0" encoding="utf-8"?>
+<a:theme xmlns:a="http://schemas.openxmlformats.org/drawingml/2006/main" name="Thème Office">
+  <a:themeElements>
+    <a:clrScheme name="Office">
+      <a:dk1>
+        <a:sysClr val="windowText" lastClr="000000"/>
+      </a:dk1>
+      <a:lt1>
+        <a:sysClr val="window" lastClr="FFFFFF"/>
+      </a:lt1>
+      <a:dk2>
+        <a:srgbClr val="44546A"/>
+      </a:dk2>
+      <a:lt2>
+        <a:srgbClr val="E7E6E6"/>
+      </a:lt2>
+      <a:accent1>
+        <a:srgbClr val="4472C4"/>
+      </a:accent1>
+      <a:accent2>
+        <a:srgbClr val="ED7D31"/>
+      </a:accent2>
+      <a:accent3>
+        <a:srgbClr val="A5A5A5"/>
+      </a:accent3>
+      <a:accent4>
+        <a:srgbClr val="FFC000"/>
+      </a:accent4>
+      <a:accent5>
+        <a:srgbClr val="5B9BD5"/>
+      </a:accent5>
+      <a:accent6>
+        <a:srgbClr val="70AD47"/>
+      </a:accent6>
+      <a:hlink>
+        <a:srgbClr val="0563C1"/>
+      </a:hlink>
+      <a:folHlink>
+        <a:srgbClr val="954F72"/>
+      </a:folHlink>
+    </a:clrScheme>
+    <a:fontScheme name="Office">
+      <a:majorFont>
+        <a:latin typeface="Calibri Light" panose="020F0302020204030204"/>
+        <a:ea typeface=""/>
+        <a:cs typeface=""/>
+        <a:font script="Jpan" typeface="游ゴシック Light"/>
+        <a:font script="Hang" typeface="맑은 고딕"/>
+        <a:font script="Hans" typeface="等线 Light"/>
+        <a:font script="Hant" typeface="新細明體"/>
+        <a:font script="Arab" typeface="Times New Roman"/>
+        <a:font script="Hebr" typeface="Times New Roman"/>
+        <a:font script="Thai" typeface="Angsana New"/>
+        <a:font script="Ethi" typeface="Nyala"/>
+        <a:font script="Beng" typeface="Vrinda"/>
+        <a:font script="Gujr" typeface="Shruti"/>
+        <a:font script="Khmr" typeface="MoolBoran"/>
+        <a:font script="Knda" typeface="Tunga"/>
+        <a:font script="Guru" typeface="Raavi"/>
+        <a:font script="Cans" typeface="Euphemia"/>
+        <a:font script="Cher" typeface="Plantagenet Cherokee"/>
+        <a:font script="Yiii" typeface="Microsoft Yi Baiti"/>
+        <a:font script="Tibt" typeface="Microsoft Himalaya"/>
+        <a:font script="Thaa" typeface="MV Boli"/>
+        <a:font script="Deva" typeface="Mangal"/>
+        <a:font script="Telu" typeface="Gautami"/>
+        <a:font script="Taml" typeface="Latha"/>
+        <a:font script="Syrc" typeface="Estrangelo Edessa"/>
+        <a:font script="Orya" typeface="Kalinga"/>
+        <a:font script="Mlym" typeface="Kartika"/>
+        <a:font script="Laoo" typeface="DokChampa"/>
+        <a:font script="Sinh" typeface="Iskoola Pota"/>
+        <a:font script="Mong" typeface="Mongolian Baiti"/>
+        <a:font script="Viet" typeface="Times New Roman"/>
+        <a:font script="Uigh" typeface="Microsoft Uighur"/>
+        <a:font script="Geor" typeface="Sylfaen"/>
+        <a:font script="Armn" typeface="Arial"/>
+        <a:font script="Bugi" typeface="Leelawadee UI"/>
+        <a:font script="Bopo" typeface="Microsoft JhengHei"/>
+        <a:font script="Java" typeface="Javanese Text"/>
+        <a:font script="Lisu" typeface="Segoe UI"/>
+        <a:font script="Mymr" typeface="Myanmar Text"/>
+        <a:font script="Nkoo" typeface="Ebrima"/>
+        <a:font script="Olck" typeface="Nirmala UI"/>
+        <a:font script="Osma" typeface="Ebrima"/>
+        <a:font script="Phag" typeface="Phagspa"/>
+        <a:font script="Syrn" typeface="Estrangelo Edessa"/>
+        <a:font script="Syrj" typeface="Estrangelo Edessa"/>
+        <a:font script="Syre" typeface="Estrangelo Edessa"/>
+        <a:font script="Sora" typeface="Nirmala UI"/>
+        <a:font script="Tale" typeface="Microsoft Tai Le"/>
+        <a:font script="Talu" typeface="Microsoft New Tai Lue"/>
+        <a:font script="Tfng" typeface="Ebrima"/>
+      </a:majorFont>
+      <a:minorFont>
+        <a:latin typeface="Calibri" panose="020F0502020204030204"/>
+        <a:ea typeface=""/>
+        <a:cs typeface=""/>
+        <a:font script="Jpan" typeface="游ゴシック"/>
+        <a:font script="Hang" typeface="맑은 고딕"/>
+        <a:font script="Hans" typeface="等线"/>
+        <a:font script="Hant" typeface="新細明體"/>
+        <a:font script="Arab" typeface="Arial"/>
+        <a:font script="Hebr" typeface="Arial"/>
+        <a:font script="Thai" typeface="Cordia New"/>
+        <a:font script="Ethi" typeface="Nyala"/>
+        <a:font script="Beng" typeface="Vrinda"/>
+        <a:font script="Gujr" typeface="Shruti"/>
+        <a:font script="Khmr" typeface="DaunPenh"/>
+        <a:font script="Knda" typeface="Tunga"/>
+        <a:font script="Guru" typeface="Raavi"/>
+        <a:font script="Cans" typeface="Euphemia"/>
+        <a:font script="Cher" typeface="Plantagenet Cherokee"/>
+        <a:font script="Yiii" typeface="Microsoft Yi Baiti"/>
+        <a:font script="Tibt" typeface="Microsoft Himalaya"/>
+        <a:font script="Thaa" typeface="MV Boli"/>
+        <a:font script="Deva" typeface="Mangal"/>
+        <a:font script="Telu" typeface="Gautami"/>
+        <a:font script="Taml" typeface="Latha"/>
+        <a:font script="Syrc" typeface="Estrangelo Edessa"/>
+        <a:font script="Orya" typeface="Kalinga"/>
+        <a:font script="Mlym" typeface="Kartika"/>
+        <a:font script="Laoo" typeface="DokChampa"/>
+        <a:font script="Sinh" typeface="Iskoola Pota"/>
+        <a:font script="Mong" typeface="Mongolian Baiti"/>
+        <a:font script="Viet" typeface="Arial"/>
+        <a:font script="Uigh" typeface="Microsoft Uighur"/>
+        <a:font script="Geor" typeface="Sylfaen"/>
+        <a:font script="Armn" typeface="Arial"/>
+        <a:font script="Bugi" typeface="Leelawadee UI"/>
+        <a:font script="Bopo" typeface="Microsoft JhengHei"/>
+        <a:font script="Java" typeface="Javanese Text"/>
+        <a:font script="Lisu" typeface="Segoe UI"/>
+        <a:font script="Mymr" typeface="Myanmar Text"/>
+        <a:font script="Nkoo" typeface="Ebrima"/>
+        <a:font script="Olck" typeface="Nirmala UI"/>
+        <a:font script="Osma" typeface="Ebrima"/>
+        <a:font script="Phag" typeface="Phagspa"/>
+        <a:font script="Syrn" typeface="Estrangelo Edessa"/>
+        <a:font script="Syrj" typeface="Estrangelo Edessa"/>
+        <a:font script="Syre" typeface="Estrangelo Edessa"/>
+        <a:font script="Sora" typeface="Nirmala UI"/>
+        <a:font script="Tale" typeface="Microsoft Tai Le"/>
+        <a:font script="Talu" typeface="Microsoft New Tai Lue"/>
+        <a:font script="Tfng" typeface="Ebrima"/>
+      </a:minorFont>
+    </a:fontScheme>
+    <a:fmtScheme name="Office">
+      <a:fillStyleLst>
+        <a:solidFill>
+          <a:schemeClr val="phClr"/>
+        </a:solidFill>
+        <a:gradFill rotWithShape="1">
+          <a:gsLst>
+            <a:gs pos="0">
+              <a:schemeClr val="phClr">
+                <a:lumMod val="110000"/>
+                <a:satMod val="105000"/>
+                <a:tint val="67000"/>
+              </a:schemeClr>
+            </a:gs>
+            <a:gs pos="50000">
+              <a:schemeClr val="phClr">
+                <a:lumMod val="105000"/>
+                <a:satMod val="103000"/>
+                <a:tint val="73000"/>
+              </a:schemeClr>
+            </a:gs>
+            <a:gs pos="100000">
+              <a:schemeClr val="phClr">
+                <a:lumMod val="105000"/>
+                <a:satMod val="109000"/>
+                <a:tint val="81000"/>
+              </a:schemeClr>
+            </a:gs>
+          </a:gsLst>
+          <a:lin ang="5400000" scaled="0"/>
+        </a:gradFill>
+        <a:gradFill rotWithShape="1">
+          <a:gsLst>
+            <a:gs pos="0">
+              <a:schemeClr val="phClr">
+                <a:satMod val="103000"/>
+                <a:lumMod val="102000"/>
+                <a:tint val="94000"/>
+              </a:schemeClr>
+            </a:gs>
+            <a:gs pos="50000">
+              <a:schemeClr val="phClr">
+                <a:satMod val="110000"/>
+                <a:lumMod val="100000"/>
+                <a:shade val="100000"/>
+              </a:schemeClr>
+            </a:gs>
+            <a:gs pos="100000">
+              <a:schemeClr val="phClr">
+                <a:lumMod val="99000"/>
+                <a:satMod val="120000"/>
+                <a:shade val="78000"/>
+              </a:schemeClr>
+            </a:gs>
+          </a:gsLst>
+          <a:lin ang="5400000" scaled="0"/>
+        </a:gradFill>
+      </a:fillStyleLst>
+      <a:lnStyleLst>
+        <a:ln w="6350" cap="flat" cmpd="sng" algn="ctr">
+          <a:solidFill>
+            <a:schemeClr val="phClr"/>
+          </a:solidFill>
+          <a:prstDash val="solid"/>
+          <a:miter lim="800000"/>
+        </a:ln>
+        <a:ln w="12700" cap="flat" cmpd="sng" algn="ctr">
+          <a:solidFill>
+            <a:schemeClr val="phClr"/>
+          </a:solidFill>
+          <a:prstDash val="solid"/>
+          <a:miter lim="800000"/>
+        </a:ln>
+        <a:ln w="19050" cap="flat" cmpd="sng" algn="ctr">
+          <a:solidFill>
+            <a:schemeClr val="phClr"/>
+          </a:solidFill>
+          <a:prstDash val="solid"/>
+          <a:miter lim="800000"/>
+        </a:ln>
+      </a:lnStyleLst>
+      <a:effectStyleLst>
+        <a:effectStyle>
+          <a:effectLst/>
+        </a:effectStyle>
+        <a:effectStyle>
+          <a:effectLst/>
+        </a:effectStyle>
+        <a:effectStyle>
+          <a:effectLst>
+            <a:outerShdw blurRad="57150" dist="19050" dir="5400000" algn="ctr" rotWithShape="0">
+              <a:srgbClr val="000000">
+                <a:alpha val="63000"/>
+              </a:srgbClr>
+            </a:outerShdw>
+          </a:effectLst>
+        </a:effectStyle>
+      </a:effectStyleLst>
+      <a:bgFillStyleLst>
+        <a:solidFill>
+          <a:schemeClr val="phClr"/>
+        </a:solidFill>
+        <a:solidFill>
+          <a:schemeClr val="phClr">
+            <a:tint val="95000"/>
+            <a:satMod val="170000"/>
+          </a:schemeClr>
+        </a:solidFill>
+        <a:gradFill rotWithShape="1">
+          <a:gsLst>
+            <a:gs pos="0">
+              <a:schemeClr val="phClr">
+                <a:tint val="93000"/>
+                <a:satMod val="150000"/>
+                <a:shade val="98000"/>
+                <a:lumMod val="102000"/>
+              </a:schemeClr>
+            </a:gs>
+            <a:gs pos="50000">
+              <a:schemeClr val="phClr">
+                <a:tint val="98000"/>
+                <a:satMod val="130000"/>
+                <a:shade val="90000"/>
+                <a:lumMod val="103000"/>
+              </a:schemeClr>
+            </a:gs>
+            <a:gs pos="100000">
+              <a:schemeClr val="phClr">
+                <a:shade val="63000"/>
+                <a:satMod val="120000"/>
+              </a:schemeClr>
+            </a:gs>
+          </a:gsLst>
+          <a:lin ang="5400000" scaled="0"/>
+        </a:gradFill>
+      </a:bgFillStyleLst>
+    </a:fmtScheme>
+  </a:themeElements>
+  <a:objectDefaults/>
+  <a:extraClrSchemeLst/>
+  <a:extLst>
+    <a:ext uri="{05A4C25C-085E-4340-85A3-A5531E510DB2}">
+      <thm15:themeFamily xmlns:thm15="http://schemas.microsoft.com/office/thememl/2012/main" name="Office Theme" id="{62F939B6-93AF-4DB8-9C6B-D6C7DFDC589F}" vid="{4A3C46E8-61CC-4603-A589-7422A47A8E4A}"/>
+    </a:ext>
+  </a:extLst>
+</a:theme>
 </file>
</xml_diff>

<commit_message>
Corrige quatre coquilles dans les notes de la soutenance
</commit_message>
<xml_diff>
--- a/docs/NexaWorks-Soutenance.pptx
+++ b/docs/NexaWorks-Soutenance.pptx
@@ -520,7 +520,7 @@
           <a:p>
             <a:r>
               <a:rPr lang="en-US"/>
-              <a:t>La procedure stockée </a:t>
+              <a:t>La procédure stockée </a:t>
             </a:r>
             <a:r>
               <a:rPr lang="en-US" dirty="0"/>
@@ -1043,7 +1043,7 @@
             </a:r>
             <a:r>
               <a:rPr lang="en-US"/>
-              <a:t>modèle compose de </a:t>
+              <a:t>modèle composé de </a:t>
             </a:r>
             <a:r>
               <a:rPr lang="en-US" dirty="0"/>
@@ -1158,7 +1158,7 @@
           <a:p>
             <a:r>
               <a:rPr lang="en-US"/>
-              <a:t>Les choix de conception : J’utilise la 3e forme normale ou le produit se déduit du ticket via sa version. Une table d'association pour le plusieurs-à-plusieurs entre versions et OS, avec une contrainte d'unicité. Une clé étrangère sur le ticket </a:t>
+              <a:t>Les choix de conception : J’utilise la 3e forme normale où le produit se déduit du ticket via sa version. Une table d'association pour le plusieurs-à-plusieurs entre versions et OS, avec une contrainte d'unicité. Une clé étrangère sur le ticket </a:t>
             </a:r>
             <a:r>
               <a:rPr lang="fr-FR" sz="1200" b="0" i="0" kern="1200">
@@ -1627,7 +1627,7 @@
             </a:r>
             <a:r>
               <a:rPr lang="en-US"/>
-              <a:t>seul enregistrement ce qui </a:t>
+              <a:t>seul enregistrement, ce qui </a:t>
             </a:r>
             <a:r>
               <a:rPr lang="en-US" dirty="0"/>

</xml_diff>

<commit_message>
Retire les notes d'orateur de la version publique du support de soutenance
</commit_message>
<xml_diff>
--- a/docs/NexaWorks-Soutenance.pptx
+++ b/docs/NexaWorks-Soutenance.pptx
@@ -295,23 +295,23 @@
           <a:p>
             <a:r>
               <a:rPr lang="en-US" dirty="0"/>
-              <a:t>Bonjour, je vais vous présenter le projet </a:t>
+              <a:t/>
             </a:r>
             <a:r>
               <a:rPr lang="en-US"/>
-              <a:t>NexaWorks qui consiste en </a:t>
+              <a:t/>
             </a:r>
             <a:r>
               <a:rPr lang="en-US" dirty="0"/>
-              <a:t>la conception et la création d'une base de données pour suivre les problèmes des logiciels de l'entreprise. </a:t>
+              <a:t/>
             </a:r>
             <a:r>
               <a:rPr lang="en-US"/>
-              <a:t>Je commence </a:t>
+              <a:t/>
             </a:r>
             <a:r>
               <a:rPr lang="en-US" dirty="0"/>
-              <a:t>par vous montrer la solution qui fonctionne, puis je détaillerai comment je l'ai construite.</a:t>
+              <a:t/>
             </a:r>
           </a:p>
         </p:txBody>
@@ -333,7 +333,7 @@
           <a:p>
             <a:fld id="{F7021451-1387-4CA6-816F-3879F97B5CBC}" type="slidenum">
               <a:rPr lang="en-US"/>
-              <a:t>1</a:t>
+              <a:t/>
             </a:fld>
             <a:endParaRPr lang="en-US"/>
           </a:p>
@@ -398,31 +398,31 @@
           <a:p>
             <a:r>
               <a:rPr lang="en-US"/>
-              <a:t>L'optimisation des requêtes: </a:t>
+              <a:t/>
             </a:r>
             <a:r>
               <a:rPr lang="en-US" dirty="0"/>
-              <a:t>les 20 requêtes ne varient que par cinq critères : statut, produit, version</a:t>
+              <a:t/>
             </a:r>
             <a:r>
               <a:rPr lang="en-US"/>
-              <a:t>, période et </a:t>
+              <a:t/>
             </a:r>
             <a:r>
               <a:rPr lang="en-US" dirty="0"/>
-              <a:t>mots-clés</a:t>
+              <a:t/>
             </a:r>
             <a:r>
               <a:rPr lang="en-US"/>
-              <a:t>. Une </a:t>
+              <a:t/>
             </a:r>
             <a:r>
               <a:rPr lang="en-US" dirty="0"/>
-              <a:t>seule requête paramétrée, où chaque critère est optionnel. Un paramètre vide est ignoré. Cette unique requête répond aux </a:t>
+              <a:t/>
             </a:r>
             <a:r>
               <a:rPr lang="en-US"/>
-              <a:t>20 demandes.</a:t>
+              <a:t/>
             </a:r>
             <a:endParaRPr lang="en-US" dirty="0"/>
           </a:p>
@@ -445,7 +445,7 @@
           <a:p>
             <a:fld id="{F7021451-1387-4CA6-816F-3879F97B5CBC}" type="slidenum">
               <a:rPr lang="en-US"/>
-              <a:t>10</a:t>
+              <a:t/>
             </a:fld>
             <a:endParaRPr lang="en-US"/>
           </a:p>
@@ -510,21 +510,21 @@
           <a:p>
             <a:r>
               <a:rPr lang="en-US" dirty="0"/>
-              <a:t>J'ai fourni la requête de deux façons : en LINQ dans le projet .NET, et en procédure stockée T-SQL dans la base. La version LINQ construit les filtres à la volée et se traduit en une seule </a:t>
+              <a:t/>
             </a:r>
             <a:r>
               <a:rPr lang="en-US"/>
-              <a:t>requête SQL.</a:t>
+              <a:t/>
             </a:r>
           </a:p>
           <a:p>
             <a:r>
               <a:rPr lang="en-US"/>
-              <a:t>La procédure stockée </a:t>
+              <a:t/>
             </a:r>
             <a:r>
               <a:rPr lang="en-US" dirty="0"/>
-              <a:t>utilise le motif paramètre-vide-ou-condition. Les deux donnent exactement les mêmes résultats.</a:t>
+              <a:t/>
             </a:r>
           </a:p>
         </p:txBody>
@@ -546,7 +546,7 @@
           <a:p>
             <a:fld id="{F7021451-1387-4CA6-816F-3879F97B5CBC}" type="slidenum">
               <a:rPr lang="en-US"/>
-              <a:t>11</a:t>
+              <a:t/>
             </a:fld>
             <a:endParaRPr lang="en-US"/>
           </a:p>
@@ -611,7 +611,7 @@
           <a:p>
             <a:r>
               <a:rPr lang="en-US" dirty="0"/>
-              <a:t>Côté documentation, un fichier Excel reprend les 20 demandes avec pour chacune le but, les paramètres, le résultat attendu et le résultat obtenu. Enfin, une sauvegarde complète de la base au format .bak, restaurable ailleurs, est déposée sur GitHub avec l'ensemble du projet.</a:t>
+              <a:t/>
             </a:r>
           </a:p>
         </p:txBody>
@@ -633,7 +633,7 @@
           <a:p>
             <a:fld id="{F7021451-1387-4CA6-816F-3879F97B5CBC}" type="slidenum">
               <a:rPr lang="en-US"/>
-              <a:t>12</a:t>
+              <a:t/>
             </a:fld>
             <a:endParaRPr lang="en-US"/>
           </a:p>
@@ -698,43 +698,43 @@
           <a:p>
             <a:r>
               <a:rPr lang="en-US"/>
-              <a:t>Ce </a:t>
+              <a:t/>
             </a:r>
             <a:r>
               <a:rPr lang="en-US" dirty="0"/>
-              <a:t>projet m'a fait progresser sur </a:t>
+              <a:t/>
             </a:r>
             <a:r>
               <a:rPr lang="en-US"/>
-              <a:t>la conception </a:t>
+              <a:t/>
             </a:r>
             <a:r>
               <a:rPr lang="en-US" dirty="0"/>
-              <a:t>et </a:t>
+              <a:t/>
             </a:r>
             <a:r>
               <a:rPr lang="en-US"/>
-              <a:t>la normalisation du schéma, </a:t>
+              <a:t/>
             </a:r>
             <a:r>
               <a:rPr lang="en-US" dirty="0"/>
-              <a:t>sur la création d'une base en Code-First avec EF Core, sur l'interrogation en LINQ et </a:t>
+              <a:t/>
             </a:r>
             <a:r>
               <a:rPr lang="en-US"/>
-              <a:t>en t-SQL </a:t>
+              <a:t/>
             </a:r>
             <a:r>
               <a:rPr lang="en-US" dirty="0"/>
-              <a:t>avec l'optimisation </a:t>
+              <a:t/>
             </a:r>
             <a:r>
               <a:rPr lang="en-US"/>
-              <a:t>des requêtes. </a:t>
+              <a:t/>
             </a:r>
             <a:r>
               <a:rPr lang="en-US" dirty="0"/>
-              <a:t>Je vous remercie et je réponds à vos questions.</a:t>
+              <a:t/>
             </a:r>
           </a:p>
         </p:txBody>
@@ -756,7 +756,7 @@
           <a:p>
             <a:fld id="{F7021451-1387-4CA6-816F-3879F97B5CBC}" type="slidenum">
               <a:rPr lang="en-US"/>
-              <a:t>13</a:t>
+              <a:t/>
             </a:fld>
             <a:endParaRPr lang="en-US"/>
           </a:p>
@@ -821,23 +821,23 @@
           <a:p>
             <a:r>
               <a:rPr lang="en-US" dirty="0"/>
-              <a:t>NexaWorks édite des logiciels, chacun en plusieurs versions, compatibles avec différents systèmes d'exploitation. L'entreprise n'a aucun outil pour tracer les problèmes rencontrés</a:t>
+              <a:t/>
             </a:r>
             <a:r>
               <a:rPr lang="en-US"/>
-              <a:t>. Je dois </a:t>
+              <a:t/>
             </a:r>
             <a:r>
               <a:rPr lang="en-US" dirty="0"/>
-              <a:t>concevoir et </a:t>
+              <a:t/>
             </a:r>
             <a:r>
               <a:rPr lang="en-US"/>
-              <a:t>créer une </a:t>
+              <a:t/>
             </a:r>
             <a:r>
               <a:rPr lang="en-US" dirty="0"/>
-              <a:t>base de données, la remplir, et fournir les requêtes pour l'interroger.</a:t>
+              <a:t/>
             </a:r>
           </a:p>
         </p:txBody>
@@ -859,7 +859,7 @@
           <a:p>
             <a:fld id="{F7021451-1387-4CA6-816F-3879F97B5CBC}" type="slidenum">
               <a:rPr lang="en-US"/>
-              <a:t>2</a:t>
+              <a:t/>
             </a:fld>
             <a:endParaRPr lang="en-US"/>
           </a:p>
@@ -924,35 +924,35 @@
           <a:p>
             <a:r>
               <a:rPr lang="en-US"/>
-              <a:t>Je vous </a:t>
+              <a:t/>
             </a:r>
             <a:r>
               <a:rPr lang="en-US" dirty="0"/>
-              <a:t>montre </a:t>
+              <a:t/>
             </a:r>
             <a:r>
               <a:rPr lang="en-US"/>
-              <a:t>d'abord le fonctionnement en démarrant le programme. </a:t>
+              <a:t/>
             </a:r>
             <a:r>
               <a:rPr lang="en-US" dirty="0"/>
-              <a:t>il remplit la </a:t>
+              <a:t/>
             </a:r>
             <a:r>
               <a:rPr lang="en-US"/>
-              <a:t>base (si elle est vide) puis </a:t>
+              <a:t/>
             </a:r>
             <a:r>
               <a:rPr lang="en-US" dirty="0"/>
-              <a:t>exécute les 20 requêtes demandées. On voit tout de </a:t>
+              <a:t/>
             </a:r>
             <a:r>
               <a:rPr lang="en-US"/>
-              <a:t>suite les résultats. J’explique ensuite comment elle a été construite</a:t>
+              <a:t/>
             </a:r>
             <a:r>
               <a:rPr lang="en-US" dirty="0"/>
-              <a:t>.</a:t>
+              <a:t/>
             </a:r>
           </a:p>
         </p:txBody>
@@ -974,7 +974,7 @@
           <a:p>
             <a:fld id="{F7021451-1387-4CA6-816F-3879F97B5CBC}" type="slidenum">
               <a:rPr lang="en-US"/>
-              <a:t>3</a:t>
+              <a:t/>
             </a:fld>
             <a:endParaRPr lang="en-US"/>
           </a:p>
@@ -1039,39 +1039,39 @@
           <a:p>
             <a:r>
               <a:rPr lang="en-US" dirty="0"/>
-              <a:t>Voici le </a:t>
+              <a:t/>
             </a:r>
             <a:r>
               <a:rPr lang="en-US"/>
-              <a:t>modèle composé de </a:t>
+              <a:t/>
             </a:r>
             <a:r>
               <a:rPr lang="en-US" dirty="0"/>
-              <a:t>six tables. Produit, Version qui appartient à un produit, OS, la table d'association Compatibilite qui </a:t>
+              <a:t/>
             </a:r>
             <a:r>
               <a:rPr lang="en-US"/>
-              <a:t>relie Versions </a:t>
+              <a:t/>
             </a:r>
             <a:r>
               <a:rPr lang="en-US" dirty="0"/>
-              <a:t>et OS, Statut</a:t>
+              <a:t/>
             </a:r>
             <a:r>
               <a:rPr lang="en-US"/>
-              <a:t>, et enfin la table Ticket qui est au centre </a:t>
+              <a:t/>
             </a:r>
             <a:r>
               <a:rPr lang="fr-FR"/>
-              <a:t>du modèle et qui référence les autres entités</a:t>
+              <a:t/>
             </a:r>
             <a:r>
               <a:rPr lang="en-US"/>
-              <a:t>. </a:t>
+              <a:t/>
             </a:r>
             <a:r>
               <a:rPr lang="en-US" dirty="0"/>
-              <a:t>Un ticket concerne une compatibilité, donc une version sur un OS, et a un statut.</a:t>
+              <a:t/>
             </a:r>
           </a:p>
         </p:txBody>
@@ -1093,7 +1093,7 @@
           <a:p>
             <a:fld id="{F7021451-1387-4CA6-816F-3879F97B5CBC}" type="slidenum">
               <a:rPr lang="en-US"/>
-              <a:t>4</a:t>
+              <a:t/>
             </a:fld>
             <a:endParaRPr lang="en-US"/>
           </a:p>
@@ -1158,7 +1158,7 @@
           <a:p>
             <a:r>
               <a:rPr lang="en-US"/>
-              <a:t>Les choix de conception : J’utilise la 3e forme normale où le produit se déduit du ticket via sa version. Une table d'association pour le plusieurs-à-plusieurs entre versions et OS, avec une contrainte d'unicité. Une clé étrangère sur le ticket </a:t>
+              <a:t/>
             </a:r>
             <a:r>
               <a:rPr lang="fr-FR" sz="1200" b="0" i="0" kern="1200">
@@ -1170,17 +1170,17 @@
                 <a:ea typeface="+mn-ea"/>
                 <a:cs typeface="+mn-cs"/>
               </a:rPr>
-              <a:t>référence un couple version + OS déjà déclaré, ce qui interdit les combinaisons impossibles.</a:t>
+              <a:t/>
             </a:r>
             <a:r>
               <a:rPr lang="en-US"/>
-              <a:t> </a:t>
+              <a:t/>
             </a:r>
           </a:p>
           <a:p>
             <a:r>
               <a:rPr lang="en-US"/>
-              <a:t>Le numéro de la table version est un champ texte (ce n'est pas un nombre).</a:t>
+              <a:t/>
             </a:r>
             <a:endParaRPr lang="en-US" dirty="0"/>
           </a:p>
@@ -1203,7 +1203,7 @@
           <a:p>
             <a:fld id="{F7021451-1387-4CA6-816F-3879F97B5CBC}" type="slidenum">
               <a:rPr lang="en-US"/>
-              <a:t>5</a:t>
+              <a:t/>
             </a:fld>
             <a:endParaRPr lang="en-US"/>
           </a:p>
@@ -1268,27 +1268,27 @@
           <a:p>
             <a:r>
               <a:rPr lang="en-US" dirty="0"/>
-              <a:t>J'ai créé 25 tickets réalistes, en respectant la matrice de compatibilité : l'OS d'un ticket est toujours compatible avec sa version. Ils couvrent les 4 produits, les 12 versions, les 6 OS</a:t>
+              <a:t/>
             </a:r>
             <a:r>
               <a:rPr lang="en-US"/>
-              <a:t>, avec au </a:t>
+              <a:t/>
             </a:r>
             <a:r>
               <a:rPr lang="en-US" dirty="0"/>
-              <a:t>moins 3 </a:t>
+              <a:t/>
             </a:r>
             <a:r>
               <a:rPr lang="en-US"/>
-              <a:t>de chaque. Au total un </a:t>
+              <a:t/>
             </a:r>
             <a:r>
               <a:rPr lang="en-US" dirty="0"/>
-              <a:t>mélange de 14 résolus et 11 </a:t>
+              <a:t/>
             </a:r>
             <a:r>
               <a:rPr lang="en-US"/>
-              <a:t>en cours.</a:t>
+              <a:t/>
             </a:r>
             <a:endParaRPr lang="en-US" dirty="0"/>
           </a:p>
@@ -1311,7 +1311,7 @@
           <a:p>
             <a:fld id="{F7021451-1387-4CA6-816F-3879F97B5CBC}" type="slidenum">
               <a:rPr lang="en-US"/>
-              <a:t>6</a:t>
+              <a:t/>
             </a:fld>
             <a:endParaRPr lang="en-US"/>
           </a:p>
@@ -1376,53 +1376,53 @@
           <a:p>
             <a:r>
               <a:rPr lang="en-US" dirty="0"/>
-              <a:t>Le premier ticket : les </a:t>
+              <a:t/>
             </a:r>
             <a:r>
               <a:rPr lang="en-US"/>
-              <a:t>cours de la bourse s’affichent à </a:t>
+              <a:t/>
             </a:r>
             <a:r>
               <a:rPr lang="en-US" dirty="0"/>
-              <a:t>0,00 sur un PC français, à cause du format des nombres</a:t>
+              <a:t/>
             </a:r>
             <a:r>
               <a:rPr lang="en-US"/>
-              <a:t>, la virgule au lieu du </a:t>
+              <a:t/>
             </a:r>
             <a:r>
               <a:rPr lang="en-US" dirty="0"/>
-              <a:t>point. En forçant un format fixe, le programme lit correctement le </a:t>
+              <a:t/>
             </a:r>
             <a:r>
               <a:rPr lang="en-US"/>
-              <a:t>point décimal. </a:t>
+              <a:t/>
             </a:r>
           </a:p>
           <a:p>
             <a:r>
               <a:rPr lang="en-US"/>
-              <a:t>Le </a:t>
+              <a:t/>
             </a:r>
             <a:r>
               <a:rPr lang="en-US" dirty="0"/>
-              <a:t>second : le solde qui ne se </a:t>
+              <a:t/>
             </a:r>
             <a:r>
               <a:rPr lang="en-US"/>
-              <a:t>rafraîchit pas à l’écran </a:t>
+              <a:t/>
             </a:r>
             <a:r>
               <a:rPr lang="en-US" dirty="0"/>
-              <a:t>; </a:t>
+              <a:t/>
             </a:r>
             <a:r>
               <a:rPr lang="en-US"/>
-              <a:t>on notifie l’interface à chaque changement de valeur, et l’écran </a:t>
+              <a:t/>
             </a:r>
             <a:r>
               <a:rPr lang="en-US" dirty="0"/>
-              <a:t>se met à jour automatiquement.</a:t>
+              <a:t/>
             </a:r>
           </a:p>
         </p:txBody>
@@ -1444,7 +1444,7 @@
           <a:p>
             <a:fld id="{F7021451-1387-4CA6-816F-3879F97B5CBC}" type="slidenum">
               <a:rPr lang="en-US"/>
-              <a:t>7</a:t>
+              <a:t/>
             </a:fld>
             <a:endParaRPr lang="en-US"/>
           </a:p>
@@ -1509,17 +1509,17 @@
           <a:p>
             <a:r>
               <a:rPr lang="en-US" dirty="0"/>
-              <a:t>J'ai choisi le Code-First : on écrit des classes C# pour chaque table, puis EF Core génère la base à partir d'une migration. C'est l'approche la plus courante en entreprise</a:t>
+              <a:t/>
             </a:r>
             <a:r>
               <a:rPr lang="en-US"/>
-              <a:t>. </a:t>
+              <a:t/>
             </a:r>
           </a:p>
           <a:p>
             <a:r>
               <a:rPr lang="en-US"/>
-              <a:t>En complément, le même schéma est écrit entièrement en T-SQL avec SQL Server Management Studio.</a:t>
+              <a:t/>
             </a:r>
             <a:endParaRPr lang="en-US" dirty="0"/>
           </a:p>
@@ -1542,7 +1542,7 @@
           <a:p>
             <a:fld id="{F7021451-1387-4CA6-816F-3879F97B5CBC}" type="slidenum">
               <a:rPr lang="en-US"/>
-              <a:t>8</a:t>
+              <a:t/>
             </a:fld>
             <a:endParaRPr lang="en-US"/>
           </a:p>
@@ -1607,41 +1607,41 @@
           <a:p>
             <a:r>
               <a:rPr lang="en-US" dirty="0"/>
-              <a:t>Pour remplir la base</a:t>
+              <a:t/>
             </a:r>
             <a:r>
               <a:rPr lang="en-US"/>
-              <a:t>, la classe DonneesInitiales.cs crée </a:t>
+              <a:t/>
             </a:r>
             <a:r>
               <a:rPr lang="en-US" dirty="0"/>
-              <a:t>les objets </a:t>
+              <a:t/>
             </a:r>
             <a:r>
               <a:rPr lang="en-US"/>
-              <a:t>et Seed.cs qui les relie à la BDD par </a:t>
+              <a:t/>
             </a:r>
             <a:r>
               <a:rPr lang="en-US" dirty="0"/>
-              <a:t>un </a:t>
+              <a:t/>
             </a:r>
             <a:r>
               <a:rPr lang="en-US"/>
-              <a:t>seul enregistrement, ce qui </a:t>
+              <a:t/>
             </a:r>
             <a:r>
               <a:rPr lang="en-US" dirty="0"/>
-              <a:t>envoie tout d'un coup dans une transaction. Au total : 4 produits, 6 OS, 2 statuts, 12 versions, 44 compatibilités et 25 </a:t>
+              <a:t/>
             </a:r>
             <a:r>
               <a:rPr lang="en-US"/>
-              <a:t>tickets.</a:t>
+              <a:t/>
             </a:r>
           </a:p>
           <a:p>
             <a:r>
               <a:rPr lang="en-US"/>
-              <a:t>Fait également en T-SQL.</a:t>
+              <a:t/>
             </a:r>
             <a:endParaRPr lang="en-US" dirty="0"/>
           </a:p>
@@ -1664,7 +1664,7 @@
           <a:p>
             <a:fld id="{F7021451-1387-4CA6-816F-3879F97B5CBC}" type="slidenum">
               <a:rPr lang="en-US"/>
-              <a:t>9</a:t>
+              <a:t/>
             </a:fld>
             <a:endParaRPr lang="en-US"/>
           </a:p>

</xml_diff>